<commit_message>
docs: embed GitHub repo and live web dashboard links into presentation slides
</commit_message>
<xml_diff>
--- a/docs/sih/SIH2026_ARIES_ALPHA-X.pptx
+++ b/docs/sih/SIH2026_ARIES_ALPHA-X.pptx
@@ -134,7 +134,7 @@
           <p:cNvPr id="2" name="Title 1">
             <a:extLst>
               <a:ext uri="{FF2B5EF4-FFF2-40B4-BE49-F238E27FC236}">
-                <a16:creationId xmlns:a16="http://schemas.microsoft.com/office/drawing/2014/main" id="{B059A24A-6632-5F65-F6D3-64DC3EEC9A4B}"/>
+                <a16:creationId xmlns:a16="http://schemas.microsoft.com/office/drawing/2014/main" id="{30C7723C-B0E5-8C40-E231-C2EC71FC6C90}"/>
               </a:ext>
             </a:extLst>
           </p:cNvPr>
@@ -172,7 +172,7 @@
           <p:cNvPr id="3" name="Subtitle 2">
             <a:extLst>
               <a:ext uri="{FF2B5EF4-FFF2-40B4-BE49-F238E27FC236}">
-                <a16:creationId xmlns:a16="http://schemas.microsoft.com/office/drawing/2014/main" id="{D24ABC70-AE0D-CE65-3BD2-F8AFCB5364A5}"/>
+                <a16:creationId xmlns:a16="http://schemas.microsoft.com/office/drawing/2014/main" id="{FC107EFC-F67A-D6F2-587B-81C91A82F594}"/>
               </a:ext>
             </a:extLst>
           </p:cNvPr>
@@ -243,7 +243,7 @@
           <p:cNvPr id="4" name="Date Placeholder 3">
             <a:extLst>
               <a:ext uri="{FF2B5EF4-FFF2-40B4-BE49-F238E27FC236}">
-                <a16:creationId xmlns:a16="http://schemas.microsoft.com/office/drawing/2014/main" id="{6430EB33-52FE-3280-659D-CE8DD3251AC2}"/>
+                <a16:creationId xmlns:a16="http://schemas.microsoft.com/office/drawing/2014/main" id="{F7A0FF65-DFF8-2C6D-8AEE-5830BE07A421}"/>
               </a:ext>
             </a:extLst>
           </p:cNvPr>
@@ -259,9 +259,9 @@
           <a:bodyPr/>
           <a:lstStyle/>
           <a:p>
-            <a:fld id="{B694C542-496D-48A7-9346-7C289C80FACF}" type="datetimeFigureOut">
+            <a:fld id="{569A5CC5-83D6-4DAD-994D-CD740F15362B}" type="datetimeFigureOut">
               <a:rPr lang="en-IN" smtClean="0"/>
-              <a:t>02-09-2026</a:t>
+              <a:t>18-09-2026</a:t>
             </a:fld>
             <a:endParaRPr lang="en-IN"/>
           </a:p>
@@ -272,7 +272,7 @@
           <p:cNvPr id="5" name="Footer Placeholder 4">
             <a:extLst>
               <a:ext uri="{FF2B5EF4-FFF2-40B4-BE49-F238E27FC236}">
-                <a16:creationId xmlns:a16="http://schemas.microsoft.com/office/drawing/2014/main" id="{1FE8FCC9-A560-D940-90E0-EF48223ADA33}"/>
+                <a16:creationId xmlns:a16="http://schemas.microsoft.com/office/drawing/2014/main" id="{831E782D-C952-D1FC-2D7C-0208D1D64B3D}"/>
               </a:ext>
             </a:extLst>
           </p:cNvPr>
@@ -297,7 +297,7 @@
           <p:cNvPr id="6" name="Slide Number Placeholder 5">
             <a:extLst>
               <a:ext uri="{FF2B5EF4-FFF2-40B4-BE49-F238E27FC236}">
-                <a16:creationId xmlns:a16="http://schemas.microsoft.com/office/drawing/2014/main" id="{381749C5-77C7-C492-4B09-F675EDCC67B8}"/>
+                <a16:creationId xmlns:a16="http://schemas.microsoft.com/office/drawing/2014/main" id="{53CB0977-F091-DDCA-1F6D-2F5798A6639A}"/>
               </a:ext>
             </a:extLst>
           </p:cNvPr>
@@ -313,7 +313,7 @@
           <a:bodyPr/>
           <a:lstStyle/>
           <a:p>
-            <a:fld id="{52B1F1DB-21F3-4B6D-A25E-7FBE60E46394}" type="slidenum">
+            <a:fld id="{0E91C0E1-239E-457A-9A95-988051D2ABD9}" type="slidenum">
               <a:rPr lang="en-IN" smtClean="0"/>
               <a:t>‹#›</a:t>
             </a:fld>
@@ -324,7 +324,7 @@
     </p:spTree>
     <p:extLst>
       <p:ext uri="{BB962C8B-B14F-4D97-AF65-F5344CB8AC3E}">
-        <p14:creationId xmlns:p14="http://schemas.microsoft.com/office/powerpoint/2010/main" val="3774135907"/>
+        <p14:creationId xmlns:p14="http://schemas.microsoft.com/office/powerpoint/2010/main" val="1584662092"/>
       </p:ext>
     </p:extLst>
   </p:cSld>
@@ -356,7 +356,7 @@
           <p:cNvPr id="2" name="Title 1">
             <a:extLst>
               <a:ext uri="{FF2B5EF4-FFF2-40B4-BE49-F238E27FC236}">
-                <a16:creationId xmlns:a16="http://schemas.microsoft.com/office/drawing/2014/main" id="{2648527E-2AF6-F2D6-7AB9-BA3903CBA70D}"/>
+                <a16:creationId xmlns:a16="http://schemas.microsoft.com/office/drawing/2014/main" id="{50C40658-2A0F-39BD-44E7-83554619FE31}"/>
               </a:ext>
             </a:extLst>
           </p:cNvPr>
@@ -385,7 +385,7 @@
           <p:cNvPr id="3" name="Vertical Text Placeholder 2">
             <a:extLst>
               <a:ext uri="{FF2B5EF4-FFF2-40B4-BE49-F238E27FC236}">
-                <a16:creationId xmlns:a16="http://schemas.microsoft.com/office/drawing/2014/main" id="{2F413D63-7FC8-1E73-BE34-DD74D6297F9D}"/>
+                <a16:creationId xmlns:a16="http://schemas.microsoft.com/office/drawing/2014/main" id="{A579D26F-8172-3A21-FE80-646862B8D7D8}"/>
               </a:ext>
             </a:extLst>
           </p:cNvPr>
@@ -443,7 +443,7 @@
           <p:cNvPr id="4" name="Date Placeholder 3">
             <a:extLst>
               <a:ext uri="{FF2B5EF4-FFF2-40B4-BE49-F238E27FC236}">
-                <a16:creationId xmlns:a16="http://schemas.microsoft.com/office/drawing/2014/main" id="{1191D155-F5D6-5958-7401-52F5B1A64AE4}"/>
+                <a16:creationId xmlns:a16="http://schemas.microsoft.com/office/drawing/2014/main" id="{6FC2786C-1800-CCB1-2A3C-AD1E1C0459DC}"/>
               </a:ext>
             </a:extLst>
           </p:cNvPr>
@@ -459,9 +459,9 @@
           <a:bodyPr/>
           <a:lstStyle/>
           <a:p>
-            <a:fld id="{B694C542-496D-48A7-9346-7C289C80FACF}" type="datetimeFigureOut">
+            <a:fld id="{569A5CC5-83D6-4DAD-994D-CD740F15362B}" type="datetimeFigureOut">
               <a:rPr lang="en-IN" smtClean="0"/>
-              <a:t>02-09-2026</a:t>
+              <a:t>18-09-2026</a:t>
             </a:fld>
             <a:endParaRPr lang="en-IN"/>
           </a:p>
@@ -472,7 +472,7 @@
           <p:cNvPr id="5" name="Footer Placeholder 4">
             <a:extLst>
               <a:ext uri="{FF2B5EF4-FFF2-40B4-BE49-F238E27FC236}">
-                <a16:creationId xmlns:a16="http://schemas.microsoft.com/office/drawing/2014/main" id="{401EE8ED-42DE-7F0B-28FF-2A0DEC403803}"/>
+                <a16:creationId xmlns:a16="http://schemas.microsoft.com/office/drawing/2014/main" id="{261C8D76-1BC9-02DA-34EF-2293C37035A0}"/>
               </a:ext>
             </a:extLst>
           </p:cNvPr>
@@ -497,7 +497,7 @@
           <p:cNvPr id="6" name="Slide Number Placeholder 5">
             <a:extLst>
               <a:ext uri="{FF2B5EF4-FFF2-40B4-BE49-F238E27FC236}">
-                <a16:creationId xmlns:a16="http://schemas.microsoft.com/office/drawing/2014/main" id="{A455E798-09E3-970C-6AD4-1D093D383489}"/>
+                <a16:creationId xmlns:a16="http://schemas.microsoft.com/office/drawing/2014/main" id="{F4AA628E-D598-E7B4-6DEC-B476C477F546}"/>
               </a:ext>
             </a:extLst>
           </p:cNvPr>
@@ -513,7 +513,7 @@
           <a:bodyPr/>
           <a:lstStyle/>
           <a:p>
-            <a:fld id="{52B1F1DB-21F3-4B6D-A25E-7FBE60E46394}" type="slidenum">
+            <a:fld id="{0E91C0E1-239E-457A-9A95-988051D2ABD9}" type="slidenum">
               <a:rPr lang="en-IN" smtClean="0"/>
               <a:t>‹#›</a:t>
             </a:fld>
@@ -524,7 +524,7 @@
     </p:spTree>
     <p:extLst>
       <p:ext uri="{BB962C8B-B14F-4D97-AF65-F5344CB8AC3E}">
-        <p14:creationId xmlns:p14="http://schemas.microsoft.com/office/powerpoint/2010/main" val="1035991360"/>
+        <p14:creationId xmlns:p14="http://schemas.microsoft.com/office/powerpoint/2010/main" val="3270027196"/>
       </p:ext>
     </p:extLst>
   </p:cSld>
@@ -556,7 +556,7 @@
           <p:cNvPr id="2" name="Vertical Title 1">
             <a:extLst>
               <a:ext uri="{FF2B5EF4-FFF2-40B4-BE49-F238E27FC236}">
-                <a16:creationId xmlns:a16="http://schemas.microsoft.com/office/drawing/2014/main" id="{B0821910-5F33-7F50-955A-5EDB419BB9DC}"/>
+                <a16:creationId xmlns:a16="http://schemas.microsoft.com/office/drawing/2014/main" id="{613D0B6C-B2DB-977E-0D75-D90909A626D3}"/>
               </a:ext>
             </a:extLst>
           </p:cNvPr>
@@ -590,7 +590,7 @@
           <p:cNvPr id="3" name="Vertical Text Placeholder 2">
             <a:extLst>
               <a:ext uri="{FF2B5EF4-FFF2-40B4-BE49-F238E27FC236}">
-                <a16:creationId xmlns:a16="http://schemas.microsoft.com/office/drawing/2014/main" id="{11A738CC-7BE8-77E4-7213-E4B3DDEFC84B}"/>
+                <a16:creationId xmlns:a16="http://schemas.microsoft.com/office/drawing/2014/main" id="{E7E8B18A-6D37-2FEE-BDB1-ED043B928BC9}"/>
               </a:ext>
             </a:extLst>
           </p:cNvPr>
@@ -653,7 +653,7 @@
           <p:cNvPr id="4" name="Date Placeholder 3">
             <a:extLst>
               <a:ext uri="{FF2B5EF4-FFF2-40B4-BE49-F238E27FC236}">
-                <a16:creationId xmlns:a16="http://schemas.microsoft.com/office/drawing/2014/main" id="{F9F71DE7-5EE6-FB41-BB79-B0789FC7B172}"/>
+                <a16:creationId xmlns:a16="http://schemas.microsoft.com/office/drawing/2014/main" id="{1EB5452A-10BA-719E-A5DD-8BDF33CD1D87}"/>
               </a:ext>
             </a:extLst>
           </p:cNvPr>
@@ -669,9 +669,9 @@
           <a:bodyPr/>
           <a:lstStyle/>
           <a:p>
-            <a:fld id="{B694C542-496D-48A7-9346-7C289C80FACF}" type="datetimeFigureOut">
+            <a:fld id="{569A5CC5-83D6-4DAD-994D-CD740F15362B}" type="datetimeFigureOut">
               <a:rPr lang="en-IN" smtClean="0"/>
-              <a:t>02-09-2026</a:t>
+              <a:t>18-09-2026</a:t>
             </a:fld>
             <a:endParaRPr lang="en-IN"/>
           </a:p>
@@ -682,7 +682,7 @@
           <p:cNvPr id="5" name="Footer Placeholder 4">
             <a:extLst>
               <a:ext uri="{FF2B5EF4-FFF2-40B4-BE49-F238E27FC236}">
-                <a16:creationId xmlns:a16="http://schemas.microsoft.com/office/drawing/2014/main" id="{22202B19-9F17-0506-92F6-0B9D094967C1}"/>
+                <a16:creationId xmlns:a16="http://schemas.microsoft.com/office/drawing/2014/main" id="{45CA515E-9C48-3461-BC2F-2F52F4A5AEAC}"/>
               </a:ext>
             </a:extLst>
           </p:cNvPr>
@@ -707,7 +707,7 @@
           <p:cNvPr id="6" name="Slide Number Placeholder 5">
             <a:extLst>
               <a:ext uri="{FF2B5EF4-FFF2-40B4-BE49-F238E27FC236}">
-                <a16:creationId xmlns:a16="http://schemas.microsoft.com/office/drawing/2014/main" id="{7C6A84C6-B0EA-19A8-6357-AB82849F7F42}"/>
+                <a16:creationId xmlns:a16="http://schemas.microsoft.com/office/drawing/2014/main" id="{45FC35FA-CFE4-893D-4441-A09DB18259E6}"/>
               </a:ext>
             </a:extLst>
           </p:cNvPr>
@@ -723,7 +723,7 @@
           <a:bodyPr/>
           <a:lstStyle/>
           <a:p>
-            <a:fld id="{52B1F1DB-21F3-4B6D-A25E-7FBE60E46394}" type="slidenum">
+            <a:fld id="{0E91C0E1-239E-457A-9A95-988051D2ABD9}" type="slidenum">
               <a:rPr lang="en-IN" smtClean="0"/>
               <a:t>‹#›</a:t>
             </a:fld>
@@ -734,7 +734,7 @@
     </p:spTree>
     <p:extLst>
       <p:ext uri="{BB962C8B-B14F-4D97-AF65-F5344CB8AC3E}">
-        <p14:creationId xmlns:p14="http://schemas.microsoft.com/office/powerpoint/2010/main" val="646393477"/>
+        <p14:creationId xmlns:p14="http://schemas.microsoft.com/office/powerpoint/2010/main" val="318156784"/>
       </p:ext>
     </p:extLst>
   </p:cSld>
@@ -766,7 +766,7 @@
           <p:cNvPr id="2" name="Title 1">
             <a:extLst>
               <a:ext uri="{FF2B5EF4-FFF2-40B4-BE49-F238E27FC236}">
-                <a16:creationId xmlns:a16="http://schemas.microsoft.com/office/drawing/2014/main" id="{8B56F401-1CC4-4351-B657-491614810975}"/>
+                <a16:creationId xmlns:a16="http://schemas.microsoft.com/office/drawing/2014/main" id="{934A5170-D7C2-C559-3CF5-869FDF8EF3AC}"/>
               </a:ext>
             </a:extLst>
           </p:cNvPr>
@@ -795,7 +795,7 @@
           <p:cNvPr id="3" name="Content Placeholder 2">
             <a:extLst>
               <a:ext uri="{FF2B5EF4-FFF2-40B4-BE49-F238E27FC236}">
-                <a16:creationId xmlns:a16="http://schemas.microsoft.com/office/drawing/2014/main" id="{57D7AB80-CC29-01D3-EB1B-5182F5213EE7}"/>
+                <a16:creationId xmlns:a16="http://schemas.microsoft.com/office/drawing/2014/main" id="{783A1573-931D-3F79-0547-9EE0E3CC4329}"/>
               </a:ext>
             </a:extLst>
           </p:cNvPr>
@@ -853,7 +853,7 @@
           <p:cNvPr id="4" name="Date Placeholder 3">
             <a:extLst>
               <a:ext uri="{FF2B5EF4-FFF2-40B4-BE49-F238E27FC236}">
-                <a16:creationId xmlns:a16="http://schemas.microsoft.com/office/drawing/2014/main" id="{EE0C16F3-FDF7-F008-60F2-EB8F2855F39F}"/>
+                <a16:creationId xmlns:a16="http://schemas.microsoft.com/office/drawing/2014/main" id="{1B7F2C49-1340-E24E-6553-BEA7DBA9A0CA}"/>
               </a:ext>
             </a:extLst>
           </p:cNvPr>
@@ -869,9 +869,9 @@
           <a:bodyPr/>
           <a:lstStyle/>
           <a:p>
-            <a:fld id="{B694C542-496D-48A7-9346-7C289C80FACF}" type="datetimeFigureOut">
+            <a:fld id="{569A5CC5-83D6-4DAD-994D-CD740F15362B}" type="datetimeFigureOut">
               <a:rPr lang="en-IN" smtClean="0"/>
-              <a:t>02-09-2026</a:t>
+              <a:t>18-09-2026</a:t>
             </a:fld>
             <a:endParaRPr lang="en-IN"/>
           </a:p>
@@ -882,7 +882,7 @@
           <p:cNvPr id="5" name="Footer Placeholder 4">
             <a:extLst>
               <a:ext uri="{FF2B5EF4-FFF2-40B4-BE49-F238E27FC236}">
-                <a16:creationId xmlns:a16="http://schemas.microsoft.com/office/drawing/2014/main" id="{61489705-1233-BB42-B71E-BBA3507D94C0}"/>
+                <a16:creationId xmlns:a16="http://schemas.microsoft.com/office/drawing/2014/main" id="{29AD5BE6-E0DB-3A48-7B7E-663881170B6B}"/>
               </a:ext>
             </a:extLst>
           </p:cNvPr>
@@ -907,7 +907,7 @@
           <p:cNvPr id="6" name="Slide Number Placeholder 5">
             <a:extLst>
               <a:ext uri="{FF2B5EF4-FFF2-40B4-BE49-F238E27FC236}">
-                <a16:creationId xmlns:a16="http://schemas.microsoft.com/office/drawing/2014/main" id="{9701B6AA-DD1E-AEB0-CCD7-A947FB6CC15C}"/>
+                <a16:creationId xmlns:a16="http://schemas.microsoft.com/office/drawing/2014/main" id="{FA565582-CBBA-9DE4-E1DE-0AB29E1A1353}"/>
               </a:ext>
             </a:extLst>
           </p:cNvPr>
@@ -923,7 +923,7 @@
           <a:bodyPr/>
           <a:lstStyle/>
           <a:p>
-            <a:fld id="{52B1F1DB-21F3-4B6D-A25E-7FBE60E46394}" type="slidenum">
+            <a:fld id="{0E91C0E1-239E-457A-9A95-988051D2ABD9}" type="slidenum">
               <a:rPr lang="en-IN" smtClean="0"/>
               <a:t>‹#›</a:t>
             </a:fld>
@@ -934,7 +934,7 @@
     </p:spTree>
     <p:extLst>
       <p:ext uri="{BB962C8B-B14F-4D97-AF65-F5344CB8AC3E}">
-        <p14:creationId xmlns:p14="http://schemas.microsoft.com/office/powerpoint/2010/main" val="3318510120"/>
+        <p14:creationId xmlns:p14="http://schemas.microsoft.com/office/powerpoint/2010/main" val="3625617371"/>
       </p:ext>
     </p:extLst>
   </p:cSld>
@@ -966,7 +966,7 @@
           <p:cNvPr id="2" name="Title 1">
             <a:extLst>
               <a:ext uri="{FF2B5EF4-FFF2-40B4-BE49-F238E27FC236}">
-                <a16:creationId xmlns:a16="http://schemas.microsoft.com/office/drawing/2014/main" id="{17A0596D-D00F-2FDF-B340-A81D0F1AD554}"/>
+                <a16:creationId xmlns:a16="http://schemas.microsoft.com/office/drawing/2014/main" id="{E79162BD-82DF-D0F9-DF93-85ACD36FA993}"/>
               </a:ext>
             </a:extLst>
           </p:cNvPr>
@@ -1004,7 +1004,7 @@
           <p:cNvPr id="3" name="Text Placeholder 2">
             <a:extLst>
               <a:ext uri="{FF2B5EF4-FFF2-40B4-BE49-F238E27FC236}">
-                <a16:creationId xmlns:a16="http://schemas.microsoft.com/office/drawing/2014/main" id="{55F0A0B8-F118-F56E-1542-B876931B07BB}"/>
+                <a16:creationId xmlns:a16="http://schemas.microsoft.com/office/drawing/2014/main" id="{0E1665D1-2ADB-113D-B833-F94F24369F15}"/>
               </a:ext>
             </a:extLst>
           </p:cNvPr>
@@ -1129,7 +1129,7 @@
           <p:cNvPr id="4" name="Date Placeholder 3">
             <a:extLst>
               <a:ext uri="{FF2B5EF4-FFF2-40B4-BE49-F238E27FC236}">
-                <a16:creationId xmlns:a16="http://schemas.microsoft.com/office/drawing/2014/main" id="{B4519BA0-8AAA-B106-B3E6-3F98631E34B8}"/>
+                <a16:creationId xmlns:a16="http://schemas.microsoft.com/office/drawing/2014/main" id="{8441E886-0EC2-EA8F-D810-FECC22A08FC9}"/>
               </a:ext>
             </a:extLst>
           </p:cNvPr>
@@ -1145,9 +1145,9 @@
           <a:bodyPr/>
           <a:lstStyle/>
           <a:p>
-            <a:fld id="{B694C542-496D-48A7-9346-7C289C80FACF}" type="datetimeFigureOut">
+            <a:fld id="{569A5CC5-83D6-4DAD-994D-CD740F15362B}" type="datetimeFigureOut">
               <a:rPr lang="en-IN" smtClean="0"/>
-              <a:t>02-09-2026</a:t>
+              <a:t>18-09-2026</a:t>
             </a:fld>
             <a:endParaRPr lang="en-IN"/>
           </a:p>
@@ -1158,7 +1158,7 @@
           <p:cNvPr id="5" name="Footer Placeholder 4">
             <a:extLst>
               <a:ext uri="{FF2B5EF4-FFF2-40B4-BE49-F238E27FC236}">
-                <a16:creationId xmlns:a16="http://schemas.microsoft.com/office/drawing/2014/main" id="{50AB55AB-D77B-434C-045E-F57F0520D391}"/>
+                <a16:creationId xmlns:a16="http://schemas.microsoft.com/office/drawing/2014/main" id="{78D1699F-1F71-69D1-75CE-D5939D2E5C3A}"/>
               </a:ext>
             </a:extLst>
           </p:cNvPr>
@@ -1183,7 +1183,7 @@
           <p:cNvPr id="6" name="Slide Number Placeholder 5">
             <a:extLst>
               <a:ext uri="{FF2B5EF4-FFF2-40B4-BE49-F238E27FC236}">
-                <a16:creationId xmlns:a16="http://schemas.microsoft.com/office/drawing/2014/main" id="{5204CA23-5EEE-2AA3-BA35-1F28AB5A362E}"/>
+                <a16:creationId xmlns:a16="http://schemas.microsoft.com/office/drawing/2014/main" id="{602243D7-7E07-0873-CE77-523FDEC79EB7}"/>
               </a:ext>
             </a:extLst>
           </p:cNvPr>
@@ -1199,7 +1199,7 @@
           <a:bodyPr/>
           <a:lstStyle/>
           <a:p>
-            <a:fld id="{52B1F1DB-21F3-4B6D-A25E-7FBE60E46394}" type="slidenum">
+            <a:fld id="{0E91C0E1-239E-457A-9A95-988051D2ABD9}" type="slidenum">
               <a:rPr lang="en-IN" smtClean="0"/>
               <a:t>‹#›</a:t>
             </a:fld>
@@ -1210,7 +1210,7 @@
     </p:spTree>
     <p:extLst>
       <p:ext uri="{BB962C8B-B14F-4D97-AF65-F5344CB8AC3E}">
-        <p14:creationId xmlns:p14="http://schemas.microsoft.com/office/powerpoint/2010/main" val="1104046027"/>
+        <p14:creationId xmlns:p14="http://schemas.microsoft.com/office/powerpoint/2010/main" val="3649294920"/>
       </p:ext>
     </p:extLst>
   </p:cSld>
@@ -1242,7 +1242,7 @@
           <p:cNvPr id="2" name="Title 1">
             <a:extLst>
               <a:ext uri="{FF2B5EF4-FFF2-40B4-BE49-F238E27FC236}">
-                <a16:creationId xmlns:a16="http://schemas.microsoft.com/office/drawing/2014/main" id="{D677B187-E786-0003-F7C2-75488F46A787}"/>
+                <a16:creationId xmlns:a16="http://schemas.microsoft.com/office/drawing/2014/main" id="{2AB482E8-5BF6-19F0-E77C-34401A5C4980}"/>
               </a:ext>
             </a:extLst>
           </p:cNvPr>
@@ -1271,7 +1271,7 @@
           <p:cNvPr id="3" name="Content Placeholder 2">
             <a:extLst>
               <a:ext uri="{FF2B5EF4-FFF2-40B4-BE49-F238E27FC236}">
-                <a16:creationId xmlns:a16="http://schemas.microsoft.com/office/drawing/2014/main" id="{12846E65-73A5-A15B-16C8-783FDBAA9FA8}"/>
+                <a16:creationId xmlns:a16="http://schemas.microsoft.com/office/drawing/2014/main" id="{268B9F64-F5AF-4AD7-3BC3-E1406389A07F}"/>
               </a:ext>
             </a:extLst>
           </p:cNvPr>
@@ -1334,7 +1334,7 @@
           <p:cNvPr id="4" name="Content Placeholder 3">
             <a:extLst>
               <a:ext uri="{FF2B5EF4-FFF2-40B4-BE49-F238E27FC236}">
-                <a16:creationId xmlns:a16="http://schemas.microsoft.com/office/drawing/2014/main" id="{FA6E2EE8-0060-2EFA-B1DF-E77B049214E7}"/>
+                <a16:creationId xmlns:a16="http://schemas.microsoft.com/office/drawing/2014/main" id="{DDCCD024-A770-91F8-5C66-710B35C8BB51}"/>
               </a:ext>
             </a:extLst>
           </p:cNvPr>
@@ -1397,7 +1397,7 @@
           <p:cNvPr id="5" name="Date Placeholder 4">
             <a:extLst>
               <a:ext uri="{FF2B5EF4-FFF2-40B4-BE49-F238E27FC236}">
-                <a16:creationId xmlns:a16="http://schemas.microsoft.com/office/drawing/2014/main" id="{3E6B2FD4-E2C1-4009-9312-D21CA5B0799B}"/>
+                <a16:creationId xmlns:a16="http://schemas.microsoft.com/office/drawing/2014/main" id="{FE4DA5E6-F410-EACF-5AB1-C760C23EC084}"/>
               </a:ext>
             </a:extLst>
           </p:cNvPr>
@@ -1413,9 +1413,9 @@
           <a:bodyPr/>
           <a:lstStyle/>
           <a:p>
-            <a:fld id="{B694C542-496D-48A7-9346-7C289C80FACF}" type="datetimeFigureOut">
+            <a:fld id="{569A5CC5-83D6-4DAD-994D-CD740F15362B}" type="datetimeFigureOut">
               <a:rPr lang="en-IN" smtClean="0"/>
-              <a:t>02-09-2026</a:t>
+              <a:t>18-09-2026</a:t>
             </a:fld>
             <a:endParaRPr lang="en-IN"/>
           </a:p>
@@ -1426,7 +1426,7 @@
           <p:cNvPr id="6" name="Footer Placeholder 5">
             <a:extLst>
               <a:ext uri="{FF2B5EF4-FFF2-40B4-BE49-F238E27FC236}">
-                <a16:creationId xmlns:a16="http://schemas.microsoft.com/office/drawing/2014/main" id="{A7E85D9B-9C58-9715-605A-F49CAEB48AE3}"/>
+                <a16:creationId xmlns:a16="http://schemas.microsoft.com/office/drawing/2014/main" id="{78579BFA-8AF5-D0A0-350A-64D6F4EFD17F}"/>
               </a:ext>
             </a:extLst>
           </p:cNvPr>
@@ -1451,7 +1451,7 @@
           <p:cNvPr id="7" name="Slide Number Placeholder 6">
             <a:extLst>
               <a:ext uri="{FF2B5EF4-FFF2-40B4-BE49-F238E27FC236}">
-                <a16:creationId xmlns:a16="http://schemas.microsoft.com/office/drawing/2014/main" id="{E06ACA6C-CE3D-055B-8848-F68D5F50D5BC}"/>
+                <a16:creationId xmlns:a16="http://schemas.microsoft.com/office/drawing/2014/main" id="{99092F18-16BC-A933-C706-6EBE372666A0}"/>
               </a:ext>
             </a:extLst>
           </p:cNvPr>
@@ -1467,7 +1467,7 @@
           <a:bodyPr/>
           <a:lstStyle/>
           <a:p>
-            <a:fld id="{52B1F1DB-21F3-4B6D-A25E-7FBE60E46394}" type="slidenum">
+            <a:fld id="{0E91C0E1-239E-457A-9A95-988051D2ABD9}" type="slidenum">
               <a:rPr lang="en-IN" smtClean="0"/>
               <a:t>‹#›</a:t>
             </a:fld>
@@ -1478,7 +1478,7 @@
     </p:spTree>
     <p:extLst>
       <p:ext uri="{BB962C8B-B14F-4D97-AF65-F5344CB8AC3E}">
-        <p14:creationId xmlns:p14="http://schemas.microsoft.com/office/powerpoint/2010/main" val="604275315"/>
+        <p14:creationId xmlns:p14="http://schemas.microsoft.com/office/powerpoint/2010/main" val="3627640206"/>
       </p:ext>
     </p:extLst>
   </p:cSld>
@@ -1510,7 +1510,7 @@
           <p:cNvPr id="2" name="Title 1">
             <a:extLst>
               <a:ext uri="{FF2B5EF4-FFF2-40B4-BE49-F238E27FC236}">
-                <a16:creationId xmlns:a16="http://schemas.microsoft.com/office/drawing/2014/main" id="{8AF6E547-C471-126D-DB9D-1B669F0104A5}"/>
+                <a16:creationId xmlns:a16="http://schemas.microsoft.com/office/drawing/2014/main" id="{F1B2E9D3-D403-D265-D5BE-CEA1F377E85E}"/>
               </a:ext>
             </a:extLst>
           </p:cNvPr>
@@ -1544,7 +1544,7 @@
           <p:cNvPr id="3" name="Text Placeholder 2">
             <a:extLst>
               <a:ext uri="{FF2B5EF4-FFF2-40B4-BE49-F238E27FC236}">
-                <a16:creationId xmlns:a16="http://schemas.microsoft.com/office/drawing/2014/main" id="{1B2E6C78-A179-2E8F-3620-290DD957EE65}"/>
+                <a16:creationId xmlns:a16="http://schemas.microsoft.com/office/drawing/2014/main" id="{2C52B79C-AD8E-7509-E637-BB0C366D3313}"/>
               </a:ext>
             </a:extLst>
           </p:cNvPr>
@@ -1615,7 +1615,7 @@
           <p:cNvPr id="4" name="Content Placeholder 3">
             <a:extLst>
               <a:ext uri="{FF2B5EF4-FFF2-40B4-BE49-F238E27FC236}">
-                <a16:creationId xmlns:a16="http://schemas.microsoft.com/office/drawing/2014/main" id="{CA0FB8B8-887F-FAFA-ACE8-6AD91C3D7065}"/>
+                <a16:creationId xmlns:a16="http://schemas.microsoft.com/office/drawing/2014/main" id="{06F50808-4336-FBFF-2033-2C1C6E7A9617}"/>
               </a:ext>
             </a:extLst>
           </p:cNvPr>
@@ -1678,7 +1678,7 @@
           <p:cNvPr id="5" name="Text Placeholder 4">
             <a:extLst>
               <a:ext uri="{FF2B5EF4-FFF2-40B4-BE49-F238E27FC236}">
-                <a16:creationId xmlns:a16="http://schemas.microsoft.com/office/drawing/2014/main" id="{19E30F67-0720-23B8-BFEE-AC75D8010EE7}"/>
+                <a16:creationId xmlns:a16="http://schemas.microsoft.com/office/drawing/2014/main" id="{0A80F4F8-3AB0-CC1D-4A83-418974E51009}"/>
               </a:ext>
             </a:extLst>
           </p:cNvPr>
@@ -1749,7 +1749,7 @@
           <p:cNvPr id="6" name="Content Placeholder 5">
             <a:extLst>
               <a:ext uri="{FF2B5EF4-FFF2-40B4-BE49-F238E27FC236}">
-                <a16:creationId xmlns:a16="http://schemas.microsoft.com/office/drawing/2014/main" id="{1268B0CC-35D3-9AC3-13EC-5E0370CF8DC9}"/>
+                <a16:creationId xmlns:a16="http://schemas.microsoft.com/office/drawing/2014/main" id="{0D148BE0-B5ED-D85F-1BFE-DEDA2FB25189}"/>
               </a:ext>
             </a:extLst>
           </p:cNvPr>
@@ -1812,7 +1812,7 @@
           <p:cNvPr id="7" name="Date Placeholder 6">
             <a:extLst>
               <a:ext uri="{FF2B5EF4-FFF2-40B4-BE49-F238E27FC236}">
-                <a16:creationId xmlns:a16="http://schemas.microsoft.com/office/drawing/2014/main" id="{73077C13-C95B-0871-F50F-2D160C32EEA9}"/>
+                <a16:creationId xmlns:a16="http://schemas.microsoft.com/office/drawing/2014/main" id="{4DC825FC-880E-7AFC-AFAB-F8D3A146C9AF}"/>
               </a:ext>
             </a:extLst>
           </p:cNvPr>
@@ -1828,9 +1828,9 @@
           <a:bodyPr/>
           <a:lstStyle/>
           <a:p>
-            <a:fld id="{B694C542-496D-48A7-9346-7C289C80FACF}" type="datetimeFigureOut">
+            <a:fld id="{569A5CC5-83D6-4DAD-994D-CD740F15362B}" type="datetimeFigureOut">
               <a:rPr lang="en-IN" smtClean="0"/>
-              <a:t>02-09-2026</a:t>
+              <a:t>18-09-2026</a:t>
             </a:fld>
             <a:endParaRPr lang="en-IN"/>
           </a:p>
@@ -1841,7 +1841,7 @@
           <p:cNvPr id="8" name="Footer Placeholder 7">
             <a:extLst>
               <a:ext uri="{FF2B5EF4-FFF2-40B4-BE49-F238E27FC236}">
-                <a16:creationId xmlns:a16="http://schemas.microsoft.com/office/drawing/2014/main" id="{15457C83-826D-48A5-4DAE-2DD07228A1EE}"/>
+                <a16:creationId xmlns:a16="http://schemas.microsoft.com/office/drawing/2014/main" id="{B02B906B-013C-E228-90B1-ABA40DA5BE78}"/>
               </a:ext>
             </a:extLst>
           </p:cNvPr>
@@ -1866,7 +1866,7 @@
           <p:cNvPr id="9" name="Slide Number Placeholder 8">
             <a:extLst>
               <a:ext uri="{FF2B5EF4-FFF2-40B4-BE49-F238E27FC236}">
-                <a16:creationId xmlns:a16="http://schemas.microsoft.com/office/drawing/2014/main" id="{B6624FB4-0C3D-CAA3-D11D-760BD95212C3}"/>
+                <a16:creationId xmlns:a16="http://schemas.microsoft.com/office/drawing/2014/main" id="{FBBEC975-66DD-4C8C-A8B6-43C5F74A9A9A}"/>
               </a:ext>
             </a:extLst>
           </p:cNvPr>
@@ -1882,7 +1882,7 @@
           <a:bodyPr/>
           <a:lstStyle/>
           <a:p>
-            <a:fld id="{52B1F1DB-21F3-4B6D-A25E-7FBE60E46394}" type="slidenum">
+            <a:fld id="{0E91C0E1-239E-457A-9A95-988051D2ABD9}" type="slidenum">
               <a:rPr lang="en-IN" smtClean="0"/>
               <a:t>‹#›</a:t>
             </a:fld>
@@ -1893,7 +1893,7 @@
     </p:spTree>
     <p:extLst>
       <p:ext uri="{BB962C8B-B14F-4D97-AF65-F5344CB8AC3E}">
-        <p14:creationId xmlns:p14="http://schemas.microsoft.com/office/powerpoint/2010/main" val="3979420863"/>
+        <p14:creationId xmlns:p14="http://schemas.microsoft.com/office/powerpoint/2010/main" val="3799956431"/>
       </p:ext>
     </p:extLst>
   </p:cSld>
@@ -1925,7 +1925,7 @@
           <p:cNvPr id="2" name="Title 1">
             <a:extLst>
               <a:ext uri="{FF2B5EF4-FFF2-40B4-BE49-F238E27FC236}">
-                <a16:creationId xmlns:a16="http://schemas.microsoft.com/office/drawing/2014/main" id="{DE446E05-642F-03D0-816B-2213F1093DCF}"/>
+                <a16:creationId xmlns:a16="http://schemas.microsoft.com/office/drawing/2014/main" id="{918168C5-E0CD-EB5C-9F41-9D384A1C94FC}"/>
               </a:ext>
             </a:extLst>
           </p:cNvPr>
@@ -1954,7 +1954,7 @@
           <p:cNvPr id="3" name="Date Placeholder 2">
             <a:extLst>
               <a:ext uri="{FF2B5EF4-FFF2-40B4-BE49-F238E27FC236}">
-                <a16:creationId xmlns:a16="http://schemas.microsoft.com/office/drawing/2014/main" id="{F9957E1A-7486-1B65-E8FF-51883EE905B6}"/>
+                <a16:creationId xmlns:a16="http://schemas.microsoft.com/office/drawing/2014/main" id="{09CFEDED-7F67-FBA7-AB54-B0BF5A1501E2}"/>
               </a:ext>
             </a:extLst>
           </p:cNvPr>
@@ -1970,9 +1970,9 @@
           <a:bodyPr/>
           <a:lstStyle/>
           <a:p>
-            <a:fld id="{B694C542-496D-48A7-9346-7C289C80FACF}" type="datetimeFigureOut">
+            <a:fld id="{569A5CC5-83D6-4DAD-994D-CD740F15362B}" type="datetimeFigureOut">
               <a:rPr lang="en-IN" smtClean="0"/>
-              <a:t>02-09-2026</a:t>
+              <a:t>18-09-2026</a:t>
             </a:fld>
             <a:endParaRPr lang="en-IN"/>
           </a:p>
@@ -1983,7 +1983,7 @@
           <p:cNvPr id="4" name="Footer Placeholder 3">
             <a:extLst>
               <a:ext uri="{FF2B5EF4-FFF2-40B4-BE49-F238E27FC236}">
-                <a16:creationId xmlns:a16="http://schemas.microsoft.com/office/drawing/2014/main" id="{61E8D348-C4EE-3F0A-D7A7-BCEC9A79848F}"/>
+                <a16:creationId xmlns:a16="http://schemas.microsoft.com/office/drawing/2014/main" id="{E3483981-45AE-6F32-6E41-4F6F3A0181CD}"/>
               </a:ext>
             </a:extLst>
           </p:cNvPr>
@@ -2008,7 +2008,7 @@
           <p:cNvPr id="5" name="Slide Number Placeholder 4">
             <a:extLst>
               <a:ext uri="{FF2B5EF4-FFF2-40B4-BE49-F238E27FC236}">
-                <a16:creationId xmlns:a16="http://schemas.microsoft.com/office/drawing/2014/main" id="{7C73F8FC-A949-0DD9-4702-E91AB65235A4}"/>
+                <a16:creationId xmlns:a16="http://schemas.microsoft.com/office/drawing/2014/main" id="{3E322187-EF7D-6422-135C-59781D7EAF3C}"/>
               </a:ext>
             </a:extLst>
           </p:cNvPr>
@@ -2024,7 +2024,7 @@
           <a:bodyPr/>
           <a:lstStyle/>
           <a:p>
-            <a:fld id="{52B1F1DB-21F3-4B6D-A25E-7FBE60E46394}" type="slidenum">
+            <a:fld id="{0E91C0E1-239E-457A-9A95-988051D2ABD9}" type="slidenum">
               <a:rPr lang="en-IN" smtClean="0"/>
               <a:t>‹#›</a:t>
             </a:fld>
@@ -2035,7 +2035,7 @@
     </p:spTree>
     <p:extLst>
       <p:ext uri="{BB962C8B-B14F-4D97-AF65-F5344CB8AC3E}">
-        <p14:creationId xmlns:p14="http://schemas.microsoft.com/office/powerpoint/2010/main" val="3413244509"/>
+        <p14:creationId xmlns:p14="http://schemas.microsoft.com/office/powerpoint/2010/main" val="4189377874"/>
       </p:ext>
     </p:extLst>
   </p:cSld>
@@ -2067,7 +2067,7 @@
           <p:cNvPr id="2" name="Date Placeholder 1">
             <a:extLst>
               <a:ext uri="{FF2B5EF4-FFF2-40B4-BE49-F238E27FC236}">
-                <a16:creationId xmlns:a16="http://schemas.microsoft.com/office/drawing/2014/main" id="{8EFB291E-7AF8-2A44-012C-94D3911129EB}"/>
+                <a16:creationId xmlns:a16="http://schemas.microsoft.com/office/drawing/2014/main" id="{3C4F2429-3893-3BFE-5BF8-A91D3BA9B361}"/>
               </a:ext>
             </a:extLst>
           </p:cNvPr>
@@ -2083,9 +2083,9 @@
           <a:bodyPr/>
           <a:lstStyle/>
           <a:p>
-            <a:fld id="{B694C542-496D-48A7-9346-7C289C80FACF}" type="datetimeFigureOut">
+            <a:fld id="{569A5CC5-83D6-4DAD-994D-CD740F15362B}" type="datetimeFigureOut">
               <a:rPr lang="en-IN" smtClean="0"/>
-              <a:t>02-09-2026</a:t>
+              <a:t>18-09-2026</a:t>
             </a:fld>
             <a:endParaRPr lang="en-IN"/>
           </a:p>
@@ -2096,7 +2096,7 @@
           <p:cNvPr id="3" name="Footer Placeholder 2">
             <a:extLst>
               <a:ext uri="{FF2B5EF4-FFF2-40B4-BE49-F238E27FC236}">
-                <a16:creationId xmlns:a16="http://schemas.microsoft.com/office/drawing/2014/main" id="{922B2BC5-2F4C-CDF0-B9F7-D526C81431B5}"/>
+                <a16:creationId xmlns:a16="http://schemas.microsoft.com/office/drawing/2014/main" id="{DA029446-1DAF-137C-416A-568400C415F3}"/>
               </a:ext>
             </a:extLst>
           </p:cNvPr>
@@ -2121,7 +2121,7 @@
           <p:cNvPr id="4" name="Slide Number Placeholder 3">
             <a:extLst>
               <a:ext uri="{FF2B5EF4-FFF2-40B4-BE49-F238E27FC236}">
-                <a16:creationId xmlns:a16="http://schemas.microsoft.com/office/drawing/2014/main" id="{D901AD28-CDD2-FCAD-8071-E95A3044151D}"/>
+                <a16:creationId xmlns:a16="http://schemas.microsoft.com/office/drawing/2014/main" id="{D8FD687A-1671-FB8C-B48A-4382406A2DDA}"/>
               </a:ext>
             </a:extLst>
           </p:cNvPr>
@@ -2137,7 +2137,7 @@
           <a:bodyPr/>
           <a:lstStyle/>
           <a:p>
-            <a:fld id="{52B1F1DB-21F3-4B6D-A25E-7FBE60E46394}" type="slidenum">
+            <a:fld id="{0E91C0E1-239E-457A-9A95-988051D2ABD9}" type="slidenum">
               <a:rPr lang="en-IN" smtClean="0"/>
               <a:t>‹#›</a:t>
             </a:fld>
@@ -2148,7 +2148,7 @@
     </p:spTree>
     <p:extLst>
       <p:ext uri="{BB962C8B-B14F-4D97-AF65-F5344CB8AC3E}">
-        <p14:creationId xmlns:p14="http://schemas.microsoft.com/office/powerpoint/2010/main" val="4026079667"/>
+        <p14:creationId xmlns:p14="http://schemas.microsoft.com/office/powerpoint/2010/main" val="716468891"/>
       </p:ext>
     </p:extLst>
   </p:cSld>
@@ -2180,7 +2180,7 @@
           <p:cNvPr id="2" name="Title 1">
             <a:extLst>
               <a:ext uri="{FF2B5EF4-FFF2-40B4-BE49-F238E27FC236}">
-                <a16:creationId xmlns:a16="http://schemas.microsoft.com/office/drawing/2014/main" id="{D19AEE5E-A3DC-117F-7D02-A81D5902E9A3}"/>
+                <a16:creationId xmlns:a16="http://schemas.microsoft.com/office/drawing/2014/main" id="{CA1675E6-DB93-E240-1CB9-6A1F53CDC4FA}"/>
               </a:ext>
             </a:extLst>
           </p:cNvPr>
@@ -2218,7 +2218,7 @@
           <p:cNvPr id="3" name="Content Placeholder 2">
             <a:extLst>
               <a:ext uri="{FF2B5EF4-FFF2-40B4-BE49-F238E27FC236}">
-                <a16:creationId xmlns:a16="http://schemas.microsoft.com/office/drawing/2014/main" id="{5480453E-DA90-CEA3-4AED-AD744B025E06}"/>
+                <a16:creationId xmlns:a16="http://schemas.microsoft.com/office/drawing/2014/main" id="{F9BFA941-10E2-7AFA-8D04-CF5DDCAB2828}"/>
               </a:ext>
             </a:extLst>
           </p:cNvPr>
@@ -2309,7 +2309,7 @@
           <p:cNvPr id="4" name="Text Placeholder 3">
             <a:extLst>
               <a:ext uri="{FF2B5EF4-FFF2-40B4-BE49-F238E27FC236}">
-                <a16:creationId xmlns:a16="http://schemas.microsoft.com/office/drawing/2014/main" id="{BD037E5E-9084-3B17-0B3E-23E7A302AFB6}"/>
+                <a16:creationId xmlns:a16="http://schemas.microsoft.com/office/drawing/2014/main" id="{514A168B-3448-2433-8561-E080897E3487}"/>
               </a:ext>
             </a:extLst>
           </p:cNvPr>
@@ -2380,7 +2380,7 @@
           <p:cNvPr id="5" name="Date Placeholder 4">
             <a:extLst>
               <a:ext uri="{FF2B5EF4-FFF2-40B4-BE49-F238E27FC236}">
-                <a16:creationId xmlns:a16="http://schemas.microsoft.com/office/drawing/2014/main" id="{5D8484D1-045A-3574-D60B-487999F00C74}"/>
+                <a16:creationId xmlns:a16="http://schemas.microsoft.com/office/drawing/2014/main" id="{E522816B-E4F3-4710-519A-2C09226CCA51}"/>
               </a:ext>
             </a:extLst>
           </p:cNvPr>
@@ -2396,9 +2396,9 @@
           <a:bodyPr/>
           <a:lstStyle/>
           <a:p>
-            <a:fld id="{B694C542-496D-48A7-9346-7C289C80FACF}" type="datetimeFigureOut">
+            <a:fld id="{569A5CC5-83D6-4DAD-994D-CD740F15362B}" type="datetimeFigureOut">
               <a:rPr lang="en-IN" smtClean="0"/>
-              <a:t>02-09-2026</a:t>
+              <a:t>18-09-2026</a:t>
             </a:fld>
             <a:endParaRPr lang="en-IN"/>
           </a:p>
@@ -2409,7 +2409,7 @@
           <p:cNvPr id="6" name="Footer Placeholder 5">
             <a:extLst>
               <a:ext uri="{FF2B5EF4-FFF2-40B4-BE49-F238E27FC236}">
-                <a16:creationId xmlns:a16="http://schemas.microsoft.com/office/drawing/2014/main" id="{FC286563-B260-C3A3-4FC9-6680F9744EA4}"/>
+                <a16:creationId xmlns:a16="http://schemas.microsoft.com/office/drawing/2014/main" id="{717D4F21-4D79-8FED-A99D-DAF98C3B333D}"/>
               </a:ext>
             </a:extLst>
           </p:cNvPr>
@@ -2434,7 +2434,7 @@
           <p:cNvPr id="7" name="Slide Number Placeholder 6">
             <a:extLst>
               <a:ext uri="{FF2B5EF4-FFF2-40B4-BE49-F238E27FC236}">
-                <a16:creationId xmlns:a16="http://schemas.microsoft.com/office/drawing/2014/main" id="{DC7A6CB6-8892-FBA9-7884-8923A9B265B7}"/>
+                <a16:creationId xmlns:a16="http://schemas.microsoft.com/office/drawing/2014/main" id="{39511757-A9FB-41B1-FBD3-446C92DB0D4C}"/>
               </a:ext>
             </a:extLst>
           </p:cNvPr>
@@ -2450,7 +2450,7 @@
           <a:bodyPr/>
           <a:lstStyle/>
           <a:p>
-            <a:fld id="{52B1F1DB-21F3-4B6D-A25E-7FBE60E46394}" type="slidenum">
+            <a:fld id="{0E91C0E1-239E-457A-9A95-988051D2ABD9}" type="slidenum">
               <a:rPr lang="en-IN" smtClean="0"/>
               <a:t>‹#›</a:t>
             </a:fld>
@@ -2461,7 +2461,7 @@
     </p:spTree>
     <p:extLst>
       <p:ext uri="{BB962C8B-B14F-4D97-AF65-F5344CB8AC3E}">
-        <p14:creationId xmlns:p14="http://schemas.microsoft.com/office/powerpoint/2010/main" val="4183352078"/>
+        <p14:creationId xmlns:p14="http://schemas.microsoft.com/office/powerpoint/2010/main" val="3759419949"/>
       </p:ext>
     </p:extLst>
   </p:cSld>
@@ -2493,7 +2493,7 @@
           <p:cNvPr id="2" name="Title 1">
             <a:extLst>
               <a:ext uri="{FF2B5EF4-FFF2-40B4-BE49-F238E27FC236}">
-                <a16:creationId xmlns:a16="http://schemas.microsoft.com/office/drawing/2014/main" id="{96ABF59E-3E14-E2D8-E9DE-026EA311245F}"/>
+                <a16:creationId xmlns:a16="http://schemas.microsoft.com/office/drawing/2014/main" id="{1E47A7C9-0424-D72E-2DC3-E672583C64AB}"/>
               </a:ext>
             </a:extLst>
           </p:cNvPr>
@@ -2531,7 +2531,7 @@
           <p:cNvPr id="3" name="Picture Placeholder 2">
             <a:extLst>
               <a:ext uri="{FF2B5EF4-FFF2-40B4-BE49-F238E27FC236}">
-                <a16:creationId xmlns:a16="http://schemas.microsoft.com/office/drawing/2014/main" id="{0DF1DB6B-B54F-E836-653C-633FA7D5917E}"/>
+                <a16:creationId xmlns:a16="http://schemas.microsoft.com/office/drawing/2014/main" id="{3E60E59B-2859-007C-6B74-7DC454C098FA}"/>
               </a:ext>
             </a:extLst>
           </p:cNvPr>
@@ -2598,7 +2598,7 @@
           <p:cNvPr id="4" name="Text Placeholder 3">
             <a:extLst>
               <a:ext uri="{FF2B5EF4-FFF2-40B4-BE49-F238E27FC236}">
-                <a16:creationId xmlns:a16="http://schemas.microsoft.com/office/drawing/2014/main" id="{7475A703-F27B-5E0D-F377-B83026069ED0}"/>
+                <a16:creationId xmlns:a16="http://schemas.microsoft.com/office/drawing/2014/main" id="{80CA42AF-1B76-1D92-0265-1DC22851F141}"/>
               </a:ext>
             </a:extLst>
           </p:cNvPr>
@@ -2669,7 +2669,7 @@
           <p:cNvPr id="5" name="Date Placeholder 4">
             <a:extLst>
               <a:ext uri="{FF2B5EF4-FFF2-40B4-BE49-F238E27FC236}">
-                <a16:creationId xmlns:a16="http://schemas.microsoft.com/office/drawing/2014/main" id="{B08D72D1-2760-8862-9EAF-B58EF7E68980}"/>
+                <a16:creationId xmlns:a16="http://schemas.microsoft.com/office/drawing/2014/main" id="{0A218FF9-34D7-C419-5BB4-8331BD7AE71B}"/>
               </a:ext>
             </a:extLst>
           </p:cNvPr>
@@ -2685,9 +2685,9 @@
           <a:bodyPr/>
           <a:lstStyle/>
           <a:p>
-            <a:fld id="{B694C542-496D-48A7-9346-7C289C80FACF}" type="datetimeFigureOut">
+            <a:fld id="{569A5CC5-83D6-4DAD-994D-CD740F15362B}" type="datetimeFigureOut">
               <a:rPr lang="en-IN" smtClean="0"/>
-              <a:t>02-09-2026</a:t>
+              <a:t>18-09-2026</a:t>
             </a:fld>
             <a:endParaRPr lang="en-IN"/>
           </a:p>
@@ -2698,7 +2698,7 @@
           <p:cNvPr id="6" name="Footer Placeholder 5">
             <a:extLst>
               <a:ext uri="{FF2B5EF4-FFF2-40B4-BE49-F238E27FC236}">
-                <a16:creationId xmlns:a16="http://schemas.microsoft.com/office/drawing/2014/main" id="{5D93E30A-D0EA-85FA-8423-236203BA18B3}"/>
+                <a16:creationId xmlns:a16="http://schemas.microsoft.com/office/drawing/2014/main" id="{AC8E5778-030D-104E-04FF-5E0ABAA2542F}"/>
               </a:ext>
             </a:extLst>
           </p:cNvPr>
@@ -2723,7 +2723,7 @@
           <p:cNvPr id="7" name="Slide Number Placeholder 6">
             <a:extLst>
               <a:ext uri="{FF2B5EF4-FFF2-40B4-BE49-F238E27FC236}">
-                <a16:creationId xmlns:a16="http://schemas.microsoft.com/office/drawing/2014/main" id="{9EE3AF9D-84D5-6F8D-5DEF-DCFDC45ADFF3}"/>
+                <a16:creationId xmlns:a16="http://schemas.microsoft.com/office/drawing/2014/main" id="{40D49E42-2FE2-3388-8543-D7FB00FAAEC8}"/>
               </a:ext>
             </a:extLst>
           </p:cNvPr>
@@ -2739,7 +2739,7 @@
           <a:bodyPr/>
           <a:lstStyle/>
           <a:p>
-            <a:fld id="{52B1F1DB-21F3-4B6D-A25E-7FBE60E46394}" type="slidenum">
+            <a:fld id="{0E91C0E1-239E-457A-9A95-988051D2ABD9}" type="slidenum">
               <a:rPr lang="en-IN" smtClean="0"/>
               <a:t>‹#›</a:t>
             </a:fld>
@@ -2750,7 +2750,7 @@
     </p:spTree>
     <p:extLst>
       <p:ext uri="{BB962C8B-B14F-4D97-AF65-F5344CB8AC3E}">
-        <p14:creationId xmlns:p14="http://schemas.microsoft.com/office/powerpoint/2010/main" val="3583507371"/>
+        <p14:creationId xmlns:p14="http://schemas.microsoft.com/office/powerpoint/2010/main" val="3359594985"/>
       </p:ext>
     </p:extLst>
   </p:cSld>
@@ -2787,7 +2787,7 @@
           <p:cNvPr id="2" name="Title Placeholder 1">
             <a:extLst>
               <a:ext uri="{FF2B5EF4-FFF2-40B4-BE49-F238E27FC236}">
-                <a16:creationId xmlns:a16="http://schemas.microsoft.com/office/drawing/2014/main" id="{5FF884C5-8A2A-76A9-553A-A8D944E60A67}"/>
+                <a16:creationId xmlns:a16="http://schemas.microsoft.com/office/drawing/2014/main" id="{6839FF73-D80B-B5A9-7AF8-3A62744C6455}"/>
               </a:ext>
             </a:extLst>
           </p:cNvPr>
@@ -2826,7 +2826,7 @@
           <p:cNvPr id="3" name="Text Placeholder 2">
             <a:extLst>
               <a:ext uri="{FF2B5EF4-FFF2-40B4-BE49-F238E27FC236}">
-                <a16:creationId xmlns:a16="http://schemas.microsoft.com/office/drawing/2014/main" id="{234B1E49-DAC4-A149-1343-74C36F2AFFAC}"/>
+                <a16:creationId xmlns:a16="http://schemas.microsoft.com/office/drawing/2014/main" id="{995C0D06-83C2-595A-6B54-F59C4037FC82}"/>
               </a:ext>
             </a:extLst>
           </p:cNvPr>
@@ -2894,7 +2894,7 @@
           <p:cNvPr id="4" name="Date Placeholder 3">
             <a:extLst>
               <a:ext uri="{FF2B5EF4-FFF2-40B4-BE49-F238E27FC236}">
-                <a16:creationId xmlns:a16="http://schemas.microsoft.com/office/drawing/2014/main" id="{E9524E69-9D62-54DF-B7C6-BD81B2C0F106}"/>
+                <a16:creationId xmlns:a16="http://schemas.microsoft.com/office/drawing/2014/main" id="{63E7221D-B03E-B1F1-05F3-A93921DC413A}"/>
               </a:ext>
             </a:extLst>
           </p:cNvPr>
@@ -2928,9 +2928,9 @@
             </a:lvl1pPr>
           </a:lstStyle>
           <a:p>
-            <a:fld id="{B694C542-496D-48A7-9346-7C289C80FACF}" type="datetimeFigureOut">
+            <a:fld id="{569A5CC5-83D6-4DAD-994D-CD740F15362B}" type="datetimeFigureOut">
               <a:rPr lang="en-IN" smtClean="0"/>
-              <a:t>02-09-2026</a:t>
+              <a:t>18-09-2026</a:t>
             </a:fld>
             <a:endParaRPr lang="en-IN"/>
           </a:p>
@@ -2941,7 +2941,7 @@
           <p:cNvPr id="5" name="Footer Placeholder 4">
             <a:extLst>
               <a:ext uri="{FF2B5EF4-FFF2-40B4-BE49-F238E27FC236}">
-                <a16:creationId xmlns:a16="http://schemas.microsoft.com/office/drawing/2014/main" id="{E7D1ED65-A6F8-0368-242C-32937F23568A}"/>
+                <a16:creationId xmlns:a16="http://schemas.microsoft.com/office/drawing/2014/main" id="{811E9B1D-6E70-0463-5506-413F38A55FBC}"/>
               </a:ext>
             </a:extLst>
           </p:cNvPr>
@@ -2984,7 +2984,7 @@
           <p:cNvPr id="6" name="Slide Number Placeholder 5">
             <a:extLst>
               <a:ext uri="{FF2B5EF4-FFF2-40B4-BE49-F238E27FC236}">
-                <a16:creationId xmlns:a16="http://schemas.microsoft.com/office/drawing/2014/main" id="{D85A2EEE-6AD2-9E35-7CF6-909F311EAC3E}"/>
+                <a16:creationId xmlns:a16="http://schemas.microsoft.com/office/drawing/2014/main" id="{2D23D2A9-9A7A-BA41-6CC0-EBA2E65CFA08}"/>
               </a:ext>
             </a:extLst>
           </p:cNvPr>
@@ -3018,7 +3018,7 @@
             </a:lvl1pPr>
           </a:lstStyle>
           <a:p>
-            <a:fld id="{52B1F1DB-21F3-4B6D-A25E-7FBE60E46394}" type="slidenum">
+            <a:fld id="{0E91C0E1-239E-457A-9A95-988051D2ABD9}" type="slidenum">
               <a:rPr lang="en-IN" smtClean="0"/>
               <a:t>‹#›</a:t>
             </a:fld>
@@ -3029,7 +3029,7 @@
     </p:spTree>
     <p:extLst>
       <p:ext uri="{BB962C8B-B14F-4D97-AF65-F5344CB8AC3E}">
-        <p14:creationId xmlns:p14="http://schemas.microsoft.com/office/powerpoint/2010/main" val="1763046431"/>
+        <p14:creationId xmlns:p14="http://schemas.microsoft.com/office/powerpoint/2010/main" val="930168073"/>
       </p:ext>
     </p:extLst>
   </p:cSld>
@@ -3352,7 +3352,7 @@
           <p:cNvPr id="2" name="Rectangle 1">
             <a:extLst>
               <a:ext uri="{FF2B5EF4-FFF2-40B4-BE49-F238E27FC236}">
-                <a16:creationId xmlns:a16="http://schemas.microsoft.com/office/drawing/2014/main" id="{20A1287F-7D04-937F-3008-93E7481E5012}"/>
+                <a16:creationId xmlns:a16="http://schemas.microsoft.com/office/drawing/2014/main" id="{8DB202E0-B6A2-09F7-C0CF-6725E5422D0F}"/>
               </a:ext>
             </a:extLst>
           </p:cNvPr>
@@ -3420,7 +3420,7 @@
           <p:cNvPr id="3" name="Rectangle: Rounded Corners 2">
             <a:extLst>
               <a:ext uri="{FF2B5EF4-FFF2-40B4-BE49-F238E27FC236}">
-                <a16:creationId xmlns:a16="http://schemas.microsoft.com/office/drawing/2014/main" id="{40F82B1D-7415-45E8-B4D7-671A524FC61E}"/>
+                <a16:creationId xmlns:a16="http://schemas.microsoft.com/office/drawing/2014/main" id="{C827FDE9-AF0B-92D6-8C0B-8A9D8D340F95}"/>
               </a:ext>
             </a:extLst>
           </p:cNvPr>
@@ -3495,7 +3495,7 @@
           <p:cNvPr id="4" name="TextBox 3">
             <a:extLst>
               <a:ext uri="{FF2B5EF4-FFF2-40B4-BE49-F238E27FC236}">
-                <a16:creationId xmlns:a16="http://schemas.microsoft.com/office/drawing/2014/main" id="{121895AE-0D45-F903-BA66-6D17FF1C95F7}"/>
+                <a16:creationId xmlns:a16="http://schemas.microsoft.com/office/drawing/2014/main" id="{DAEA74D9-CC53-078B-89A4-17ED4EDCAFAA}"/>
               </a:ext>
             </a:extLst>
           </p:cNvPr>
@@ -3534,7 +3534,7 @@
           <p:cNvPr id="5" name="TextBox 4">
             <a:extLst>
               <a:ext uri="{FF2B5EF4-FFF2-40B4-BE49-F238E27FC236}">
-                <a16:creationId xmlns:a16="http://schemas.microsoft.com/office/drawing/2014/main" id="{81AE775F-A442-4307-245E-2E04A1F8BA5C}"/>
+                <a16:creationId xmlns:a16="http://schemas.microsoft.com/office/drawing/2014/main" id="{EC0D8F9E-E230-8151-505B-9012E793D734}"/>
               </a:ext>
             </a:extLst>
           </p:cNvPr>
@@ -3578,7 +3578,7 @@
           <p:cNvPr id="6" name="Rectangle: Rounded Corners 5">
             <a:extLst>
               <a:ext uri="{FF2B5EF4-FFF2-40B4-BE49-F238E27FC236}">
-                <a16:creationId xmlns:a16="http://schemas.microsoft.com/office/drawing/2014/main" id="{A63A4B4A-2C89-711F-7F67-52432BB783A2}"/>
+                <a16:creationId xmlns:a16="http://schemas.microsoft.com/office/drawing/2014/main" id="{9079AA52-6C69-935E-980B-1645A34DAB43}"/>
               </a:ext>
             </a:extLst>
           </p:cNvPr>
@@ -3655,7 +3655,7 @@
           <p:cNvPr id="7" name="Rectangle: Rounded Corners 6">
             <a:extLst>
               <a:ext uri="{FF2B5EF4-FFF2-40B4-BE49-F238E27FC236}">
-                <a16:creationId xmlns:a16="http://schemas.microsoft.com/office/drawing/2014/main" id="{C6F5C8DE-772F-72C9-5EDD-93615BF56768}"/>
+                <a16:creationId xmlns:a16="http://schemas.microsoft.com/office/drawing/2014/main" id="{C4CAE876-A716-3B30-CD64-90E16FC25EF5}"/>
               </a:ext>
             </a:extLst>
           </p:cNvPr>
@@ -3732,7 +3732,7 @@
           <p:cNvPr id="8" name="Rectangle: Rounded Corners 7">
             <a:extLst>
               <a:ext uri="{FF2B5EF4-FFF2-40B4-BE49-F238E27FC236}">
-                <a16:creationId xmlns:a16="http://schemas.microsoft.com/office/drawing/2014/main" id="{8FDDF11B-F30B-8E28-22AD-A0B6A5EA5D1C}"/>
+                <a16:creationId xmlns:a16="http://schemas.microsoft.com/office/drawing/2014/main" id="{EF025D13-F2F2-D52F-EAC8-F9FC955D8598}"/>
               </a:ext>
             </a:extLst>
           </p:cNvPr>
@@ -3804,7 +3804,7 @@
           <p:cNvPr id="10" name="Picture 9">
             <a:extLst>
               <a:ext uri="{FF2B5EF4-FFF2-40B4-BE49-F238E27FC236}">
-                <a16:creationId xmlns:a16="http://schemas.microsoft.com/office/drawing/2014/main" id="{88EA721F-734B-9416-BB32-BAD3C58BD37B}"/>
+                <a16:creationId xmlns:a16="http://schemas.microsoft.com/office/drawing/2014/main" id="{8A869A44-6552-3B0D-22E5-9BEB339E2FCF}"/>
               </a:ext>
             </a:extLst>
           </p:cNvPr>
@@ -3840,7 +3840,7 @@
           <p:cNvPr id="11" name="Rectangle 10">
             <a:extLst>
               <a:ext uri="{FF2B5EF4-FFF2-40B4-BE49-F238E27FC236}">
-                <a16:creationId xmlns:a16="http://schemas.microsoft.com/office/drawing/2014/main" id="{5B8BE88B-1C17-E173-F177-FF6C0C837780}"/>
+                <a16:creationId xmlns:a16="http://schemas.microsoft.com/office/drawing/2014/main" id="{F93F8B4A-4306-7DFC-9DEF-1939EBDF960D}"/>
               </a:ext>
             </a:extLst>
           </p:cNvPr>
@@ -3908,7 +3908,7 @@
           <p:cNvPr id="12" name="TextBox 11">
             <a:extLst>
               <a:ext uri="{FF2B5EF4-FFF2-40B4-BE49-F238E27FC236}">
-                <a16:creationId xmlns:a16="http://schemas.microsoft.com/office/drawing/2014/main" id="{2EC5B903-8FF5-71FE-95C4-E7F1A933D766}"/>
+                <a16:creationId xmlns:a16="http://schemas.microsoft.com/office/drawing/2014/main" id="{431D08AE-BECE-D080-AF72-AA215CD50625}"/>
               </a:ext>
             </a:extLst>
           </p:cNvPr>
@@ -3932,25 +3932,20 @@
           <a:lstStyle/>
           <a:p>
             <a:r>
-              <a:rPr lang="en-US" sz="1200" b="1">
+              <a:rPr lang="en-IN" sz="1200" b="1">
                 <a:solidFill>
                   <a:srgbClr val="FFB300"/>
                 </a:solidFill>
               </a:rPr>
-              <a:t>Team: ALPHA-X   |   Theme: Disaster Management   |   PS ID: SIH26223   |   Category: Hardware &amp; Edge AI</a:t>
-            </a:r>
-            <a:endParaRPr lang="en-IN" sz="1200" b="1">
-              <a:solidFill>
-                <a:srgbClr val="FFB300"/>
-              </a:solidFill>
-            </a:endParaRPr>
+              <a:t>Team: ALPHA-X   |   PS ID: SIH26223   |   GitHub: github.com/harshitsharma120109-web/ARIES-Search-Rescue-Rover</a:t>
+            </a:r>
           </a:p>
         </p:txBody>
       </p:sp>
     </p:spTree>
     <p:extLst>
       <p:ext uri="{BB962C8B-B14F-4D97-AF65-F5344CB8AC3E}">
-        <p14:creationId xmlns:p14="http://schemas.microsoft.com/office/powerpoint/2010/main" val="2905244460"/>
+        <p14:creationId xmlns:p14="http://schemas.microsoft.com/office/powerpoint/2010/main" val="772420421"/>
       </p:ext>
     </p:extLst>
   </p:cSld>
@@ -3982,7 +3977,7 @@
           <p:cNvPr id="2" name="Rectangle 1">
             <a:extLst>
               <a:ext uri="{FF2B5EF4-FFF2-40B4-BE49-F238E27FC236}">
-                <a16:creationId xmlns:a16="http://schemas.microsoft.com/office/drawing/2014/main" id="{B0A755B4-55E5-D98C-125E-1D1577B359CF}"/>
+                <a16:creationId xmlns:a16="http://schemas.microsoft.com/office/drawing/2014/main" id="{4132AA00-931B-3FB8-2E57-430DC13895D9}"/>
               </a:ext>
             </a:extLst>
           </p:cNvPr>
@@ -4050,7 +4045,7 @@
           <p:cNvPr id="3" name="Rectangle 2">
             <a:extLst>
               <a:ext uri="{FF2B5EF4-FFF2-40B4-BE49-F238E27FC236}">
-                <a16:creationId xmlns:a16="http://schemas.microsoft.com/office/drawing/2014/main" id="{F524FABC-3DA9-1EFD-0728-5607C8579B24}"/>
+                <a16:creationId xmlns:a16="http://schemas.microsoft.com/office/drawing/2014/main" id="{D67300AD-0EAA-C2E1-BA7F-78D57E0307C4}"/>
               </a:ext>
             </a:extLst>
           </p:cNvPr>
@@ -4118,7 +4113,7 @@
           <p:cNvPr id="4" name="Rectangle: Rounded Corners 3">
             <a:extLst>
               <a:ext uri="{FF2B5EF4-FFF2-40B4-BE49-F238E27FC236}">
-                <a16:creationId xmlns:a16="http://schemas.microsoft.com/office/drawing/2014/main" id="{7596719A-EA26-7759-15DD-546D7985A6E5}"/>
+                <a16:creationId xmlns:a16="http://schemas.microsoft.com/office/drawing/2014/main" id="{74B86998-A89F-D769-0548-4D693637D356}"/>
               </a:ext>
             </a:extLst>
           </p:cNvPr>
@@ -4193,7 +4188,7 @@
           <p:cNvPr id="5" name="TextBox 4">
             <a:extLst>
               <a:ext uri="{FF2B5EF4-FFF2-40B4-BE49-F238E27FC236}">
-                <a16:creationId xmlns:a16="http://schemas.microsoft.com/office/drawing/2014/main" id="{4C1F23A1-88DF-BDBD-1B10-3616C8DEA7A8}"/>
+                <a16:creationId xmlns:a16="http://schemas.microsoft.com/office/drawing/2014/main" id="{C1C48695-4105-B955-F1DD-8956B61EF483}"/>
               </a:ext>
             </a:extLst>
           </p:cNvPr>
@@ -4232,7 +4227,7 @@
           <p:cNvPr id="6" name="Rectangle: Rounded Corners 5">
             <a:extLst>
               <a:ext uri="{FF2B5EF4-FFF2-40B4-BE49-F238E27FC236}">
-                <a16:creationId xmlns:a16="http://schemas.microsoft.com/office/drawing/2014/main" id="{F4AF43BE-FD4D-72A2-7AE2-25111E45769A}"/>
+                <a16:creationId xmlns:a16="http://schemas.microsoft.com/office/drawing/2014/main" id="{1D1D6B4D-34FC-5017-4645-940794E98832}"/>
               </a:ext>
             </a:extLst>
           </p:cNvPr>
@@ -4293,7 +4288,7 @@
           <p:cNvPr id="7" name="Rectangle: Rounded Corners 6">
             <a:extLst>
               <a:ext uri="{FF2B5EF4-FFF2-40B4-BE49-F238E27FC236}">
-                <a16:creationId xmlns:a16="http://schemas.microsoft.com/office/drawing/2014/main" id="{20F40899-1000-44B7-4A46-01C0FD06370C}"/>
+                <a16:creationId xmlns:a16="http://schemas.microsoft.com/office/drawing/2014/main" id="{4656CC03-78F6-8E5E-E7DC-93FA776250F3}"/>
               </a:ext>
             </a:extLst>
           </p:cNvPr>
@@ -4373,7 +4368,7 @@
           <p:cNvPr id="8" name="Rectangle: Rounded Corners 7">
             <a:extLst>
               <a:ext uri="{FF2B5EF4-FFF2-40B4-BE49-F238E27FC236}">
-                <a16:creationId xmlns:a16="http://schemas.microsoft.com/office/drawing/2014/main" id="{E30BB334-5019-4E18-230B-5EF459415610}"/>
+                <a16:creationId xmlns:a16="http://schemas.microsoft.com/office/drawing/2014/main" id="{4DCA992C-BE58-421E-F542-8B3221BED149}"/>
               </a:ext>
             </a:extLst>
           </p:cNvPr>
@@ -4452,7 +4447,7 @@
           <p:cNvPr id="9" name="Rectangle: Rounded Corners 8">
             <a:extLst>
               <a:ext uri="{FF2B5EF4-FFF2-40B4-BE49-F238E27FC236}">
-                <a16:creationId xmlns:a16="http://schemas.microsoft.com/office/drawing/2014/main" id="{AF525210-EF62-29F8-3BEB-54C39C168549}"/>
+                <a16:creationId xmlns:a16="http://schemas.microsoft.com/office/drawing/2014/main" id="{5A9B5555-22A2-7EFC-C294-28ECA8EA4654}"/>
               </a:ext>
             </a:extLst>
           </p:cNvPr>
@@ -4532,7 +4527,7 @@
           <p:cNvPr id="10" name="Rectangle: Rounded Corners 9">
             <a:extLst>
               <a:ext uri="{FF2B5EF4-FFF2-40B4-BE49-F238E27FC236}">
-                <a16:creationId xmlns:a16="http://schemas.microsoft.com/office/drawing/2014/main" id="{C365571D-8EA6-7D7C-171C-3B430BF20DBD}"/>
+                <a16:creationId xmlns:a16="http://schemas.microsoft.com/office/drawing/2014/main" id="{61DC5581-6EE5-A220-F79A-89A48B091B9B}"/>
               </a:ext>
             </a:extLst>
           </p:cNvPr>
@@ -4604,7 +4599,7 @@
           <p:cNvPr id="12" name="Picture 11">
             <a:extLst>
               <a:ext uri="{FF2B5EF4-FFF2-40B4-BE49-F238E27FC236}">
-                <a16:creationId xmlns:a16="http://schemas.microsoft.com/office/drawing/2014/main" id="{EDDB6333-A513-D618-BE79-F1DAF3116337}"/>
+                <a16:creationId xmlns:a16="http://schemas.microsoft.com/office/drawing/2014/main" id="{418B3E0E-88C3-6510-E36B-F0C684E9D6A5}"/>
               </a:ext>
             </a:extLst>
           </p:cNvPr>
@@ -4640,7 +4635,7 @@
           <p:cNvPr id="13" name="Rectangle 12">
             <a:extLst>
               <a:ext uri="{FF2B5EF4-FFF2-40B4-BE49-F238E27FC236}">
-                <a16:creationId xmlns:a16="http://schemas.microsoft.com/office/drawing/2014/main" id="{B8FB1230-6E80-3A4B-E4BD-4D807616E2D9}"/>
+                <a16:creationId xmlns:a16="http://schemas.microsoft.com/office/drawing/2014/main" id="{BD3B9629-9297-87AC-D971-C19EC0E94B02}"/>
               </a:ext>
             </a:extLst>
           </p:cNvPr>
@@ -4708,7 +4703,7 @@
           <p:cNvPr id="14" name="TextBox 13">
             <a:extLst>
               <a:ext uri="{FF2B5EF4-FFF2-40B4-BE49-F238E27FC236}">
-                <a16:creationId xmlns:a16="http://schemas.microsoft.com/office/drawing/2014/main" id="{43774E30-D7F5-8112-026B-68C130B72DA0}"/>
+                <a16:creationId xmlns:a16="http://schemas.microsoft.com/office/drawing/2014/main" id="{63508FC1-A76C-B79A-7CD0-5A1195BFEF53}"/>
               </a:ext>
             </a:extLst>
           </p:cNvPr>
@@ -4750,7 +4745,7 @@
     </p:spTree>
     <p:extLst>
       <p:ext uri="{BB962C8B-B14F-4D97-AF65-F5344CB8AC3E}">
-        <p14:creationId xmlns:p14="http://schemas.microsoft.com/office/powerpoint/2010/main" val="3102055666"/>
+        <p14:creationId xmlns:p14="http://schemas.microsoft.com/office/powerpoint/2010/main" val="544163845"/>
       </p:ext>
     </p:extLst>
   </p:cSld>
@@ -4782,7 +4777,7 @@
           <p:cNvPr id="2" name="Rectangle 1">
             <a:extLst>
               <a:ext uri="{FF2B5EF4-FFF2-40B4-BE49-F238E27FC236}">
-                <a16:creationId xmlns:a16="http://schemas.microsoft.com/office/drawing/2014/main" id="{F7C37D0D-2237-7E1D-AF74-69A3B36FCD6E}"/>
+                <a16:creationId xmlns:a16="http://schemas.microsoft.com/office/drawing/2014/main" id="{E6809A52-A115-9D73-9345-D2696C0846DE}"/>
               </a:ext>
             </a:extLst>
           </p:cNvPr>
@@ -4850,7 +4845,7 @@
           <p:cNvPr id="3" name="Rectangle 2">
             <a:extLst>
               <a:ext uri="{FF2B5EF4-FFF2-40B4-BE49-F238E27FC236}">
-                <a16:creationId xmlns:a16="http://schemas.microsoft.com/office/drawing/2014/main" id="{9CB66828-B719-D29E-2BD0-A6906916EA45}"/>
+                <a16:creationId xmlns:a16="http://schemas.microsoft.com/office/drawing/2014/main" id="{561A6580-FC1F-843C-919E-F69D093BFCDF}"/>
               </a:ext>
             </a:extLst>
           </p:cNvPr>
@@ -4918,7 +4913,7 @@
           <p:cNvPr id="4" name="Rectangle: Rounded Corners 3">
             <a:extLst>
               <a:ext uri="{FF2B5EF4-FFF2-40B4-BE49-F238E27FC236}">
-                <a16:creationId xmlns:a16="http://schemas.microsoft.com/office/drawing/2014/main" id="{628559DA-2A3B-AA0C-3479-D1FD9EB842B1}"/>
+                <a16:creationId xmlns:a16="http://schemas.microsoft.com/office/drawing/2014/main" id="{3398D6A3-F352-D5AD-F7DB-BDE57E31E0DA}"/>
               </a:ext>
             </a:extLst>
           </p:cNvPr>
@@ -4993,7 +4988,7 @@
           <p:cNvPr id="5" name="TextBox 4">
             <a:extLst>
               <a:ext uri="{FF2B5EF4-FFF2-40B4-BE49-F238E27FC236}">
-                <a16:creationId xmlns:a16="http://schemas.microsoft.com/office/drawing/2014/main" id="{00114DFE-14DC-ADCB-88DA-6D835EF7BE18}"/>
+                <a16:creationId xmlns:a16="http://schemas.microsoft.com/office/drawing/2014/main" id="{F5EBAC96-BD00-53C8-EAFE-B8F4FB61512A}"/>
               </a:ext>
             </a:extLst>
           </p:cNvPr>
@@ -5032,7 +5027,7 @@
           <p:cNvPr id="6" name="Rectangle: Rounded Corners 5">
             <a:extLst>
               <a:ext uri="{FF2B5EF4-FFF2-40B4-BE49-F238E27FC236}">
-                <a16:creationId xmlns:a16="http://schemas.microsoft.com/office/drawing/2014/main" id="{13BAB04A-1E39-DB54-6B6E-8F4897B82576}"/>
+                <a16:creationId xmlns:a16="http://schemas.microsoft.com/office/drawing/2014/main" id="{817E1474-E34D-1FEB-9FC9-97C577B19E8A}"/>
               </a:ext>
             </a:extLst>
           </p:cNvPr>
@@ -5093,7 +5088,7 @@
           <p:cNvPr id="7" name="Rectangle: Rounded Corners 6">
             <a:extLst>
               <a:ext uri="{FF2B5EF4-FFF2-40B4-BE49-F238E27FC236}">
-                <a16:creationId xmlns:a16="http://schemas.microsoft.com/office/drawing/2014/main" id="{08715DD3-E68F-6DAD-CFA9-2A29040976C7}"/>
+                <a16:creationId xmlns:a16="http://schemas.microsoft.com/office/drawing/2014/main" id="{819FD8E5-C2B2-86F1-5932-7D7911B527FF}"/>
               </a:ext>
             </a:extLst>
           </p:cNvPr>
@@ -5179,7 +5174,7 @@
           <p:cNvPr id="8" name="Rectangle: Rounded Corners 7">
             <a:extLst>
               <a:ext uri="{FF2B5EF4-FFF2-40B4-BE49-F238E27FC236}">
-                <a16:creationId xmlns:a16="http://schemas.microsoft.com/office/drawing/2014/main" id="{2D9A4F2B-EF56-8955-A19A-DECF96AB67BA}"/>
+                <a16:creationId xmlns:a16="http://schemas.microsoft.com/office/drawing/2014/main" id="{7A70E16B-50CF-EF4B-1D1E-5395C33EB052}"/>
               </a:ext>
             </a:extLst>
           </p:cNvPr>
@@ -5272,7 +5267,7 @@
           <p:cNvPr id="9" name="Rectangle: Rounded Corners 8">
             <a:extLst>
               <a:ext uri="{FF2B5EF4-FFF2-40B4-BE49-F238E27FC236}">
-                <a16:creationId xmlns:a16="http://schemas.microsoft.com/office/drawing/2014/main" id="{CFF108B6-C39C-58D1-2A90-121F461ED3A5}"/>
+                <a16:creationId xmlns:a16="http://schemas.microsoft.com/office/drawing/2014/main" id="{80508671-BAD8-005F-31FD-EBF143AF7E84}"/>
               </a:ext>
             </a:extLst>
           </p:cNvPr>
@@ -5358,7 +5353,7 @@
           <p:cNvPr id="11" name="Picture 10">
             <a:extLst>
               <a:ext uri="{FF2B5EF4-FFF2-40B4-BE49-F238E27FC236}">
-                <a16:creationId xmlns:a16="http://schemas.microsoft.com/office/drawing/2014/main" id="{61A6FF30-EB5A-8346-85B6-08057975974F}"/>
+                <a16:creationId xmlns:a16="http://schemas.microsoft.com/office/drawing/2014/main" id="{EE60A399-9E70-BE51-21F6-AF2DF417561D}"/>
               </a:ext>
             </a:extLst>
           </p:cNvPr>
@@ -5394,7 +5389,7 @@
           <p:cNvPr id="12" name="Rectangle 11">
             <a:extLst>
               <a:ext uri="{FF2B5EF4-FFF2-40B4-BE49-F238E27FC236}">
-                <a16:creationId xmlns:a16="http://schemas.microsoft.com/office/drawing/2014/main" id="{CC14A7EA-1DDB-65DD-3EAE-B6390FB57109}"/>
+                <a16:creationId xmlns:a16="http://schemas.microsoft.com/office/drawing/2014/main" id="{CE02373E-5D61-BB40-05C3-CC7A0776CB2E}"/>
               </a:ext>
             </a:extLst>
           </p:cNvPr>
@@ -5462,7 +5457,7 @@
           <p:cNvPr id="13" name="TextBox 12">
             <a:extLst>
               <a:ext uri="{FF2B5EF4-FFF2-40B4-BE49-F238E27FC236}">
-                <a16:creationId xmlns:a16="http://schemas.microsoft.com/office/drawing/2014/main" id="{04EA808B-36B6-EC6B-BD62-1BF0C430DD76}"/>
+                <a16:creationId xmlns:a16="http://schemas.microsoft.com/office/drawing/2014/main" id="{AAFE275C-212B-2E23-813A-80A23490ECCA}"/>
               </a:ext>
             </a:extLst>
           </p:cNvPr>
@@ -5504,7 +5499,7 @@
     </p:spTree>
     <p:extLst>
       <p:ext uri="{BB962C8B-B14F-4D97-AF65-F5344CB8AC3E}">
-        <p14:creationId xmlns:p14="http://schemas.microsoft.com/office/powerpoint/2010/main" val="1236830096"/>
+        <p14:creationId xmlns:p14="http://schemas.microsoft.com/office/powerpoint/2010/main" val="2463768823"/>
       </p:ext>
     </p:extLst>
   </p:cSld>
@@ -5536,7 +5531,7 @@
           <p:cNvPr id="2" name="Rectangle 1">
             <a:extLst>
               <a:ext uri="{FF2B5EF4-FFF2-40B4-BE49-F238E27FC236}">
-                <a16:creationId xmlns:a16="http://schemas.microsoft.com/office/drawing/2014/main" id="{3B566DC3-70AD-9A48-E1D7-88134F66CB56}"/>
+                <a16:creationId xmlns:a16="http://schemas.microsoft.com/office/drawing/2014/main" id="{49E27865-02F9-4D2F-3DB4-B0851F20384E}"/>
               </a:ext>
             </a:extLst>
           </p:cNvPr>
@@ -5604,7 +5599,7 @@
           <p:cNvPr id="3" name="Rectangle 2">
             <a:extLst>
               <a:ext uri="{FF2B5EF4-FFF2-40B4-BE49-F238E27FC236}">
-                <a16:creationId xmlns:a16="http://schemas.microsoft.com/office/drawing/2014/main" id="{8F781C8C-487B-D7F8-EAE7-F5CC92C49E8B}"/>
+                <a16:creationId xmlns:a16="http://schemas.microsoft.com/office/drawing/2014/main" id="{849FA933-DEA7-0F14-47A7-0971F4AC7E58}"/>
               </a:ext>
             </a:extLst>
           </p:cNvPr>
@@ -5672,7 +5667,7 @@
           <p:cNvPr id="4" name="Rectangle: Rounded Corners 3">
             <a:extLst>
               <a:ext uri="{FF2B5EF4-FFF2-40B4-BE49-F238E27FC236}">
-                <a16:creationId xmlns:a16="http://schemas.microsoft.com/office/drawing/2014/main" id="{DA7A9DBB-57A5-0A6C-A5C1-743DB5EAC0F9}"/>
+                <a16:creationId xmlns:a16="http://schemas.microsoft.com/office/drawing/2014/main" id="{98F03A7B-648D-2C4E-99A6-9A8ED445EA11}"/>
               </a:ext>
             </a:extLst>
           </p:cNvPr>
@@ -5747,7 +5742,7 @@
           <p:cNvPr id="5" name="TextBox 4">
             <a:extLst>
               <a:ext uri="{FF2B5EF4-FFF2-40B4-BE49-F238E27FC236}">
-                <a16:creationId xmlns:a16="http://schemas.microsoft.com/office/drawing/2014/main" id="{84C86A18-CF9F-E025-B1C3-9301EE7D4FA4}"/>
+                <a16:creationId xmlns:a16="http://schemas.microsoft.com/office/drawing/2014/main" id="{629F70ED-F8AA-9639-0D35-127258C0F170}"/>
               </a:ext>
             </a:extLst>
           </p:cNvPr>
@@ -5786,7 +5781,7 @@
           <p:cNvPr id="6" name="Rectangle: Rounded Corners 5">
             <a:extLst>
               <a:ext uri="{FF2B5EF4-FFF2-40B4-BE49-F238E27FC236}">
-                <a16:creationId xmlns:a16="http://schemas.microsoft.com/office/drawing/2014/main" id="{1CC01312-FDE7-2226-FB5A-3DFCB400F441}"/>
+                <a16:creationId xmlns:a16="http://schemas.microsoft.com/office/drawing/2014/main" id="{F9B013DA-19CD-1520-CCC9-12FB74F805D4}"/>
               </a:ext>
             </a:extLst>
           </p:cNvPr>
@@ -5847,7 +5842,7 @@
           <p:cNvPr id="7" name="Rectangle: Rounded Corners 6">
             <a:extLst>
               <a:ext uri="{FF2B5EF4-FFF2-40B4-BE49-F238E27FC236}">
-                <a16:creationId xmlns:a16="http://schemas.microsoft.com/office/drawing/2014/main" id="{2BAAE70A-FBF4-1D5F-F90A-B8DC6D63C2FB}"/>
+                <a16:creationId xmlns:a16="http://schemas.microsoft.com/office/drawing/2014/main" id="{B7DFB654-8678-DBBD-922A-C98214912984}"/>
               </a:ext>
             </a:extLst>
           </p:cNvPr>
@@ -5933,7 +5928,7 @@
           <p:cNvPr id="8" name="Rectangle: Rounded Corners 7">
             <a:extLst>
               <a:ext uri="{FF2B5EF4-FFF2-40B4-BE49-F238E27FC236}">
-                <a16:creationId xmlns:a16="http://schemas.microsoft.com/office/drawing/2014/main" id="{47F60BA3-461B-8121-B5E8-61D8CBFA1BB2}"/>
+                <a16:creationId xmlns:a16="http://schemas.microsoft.com/office/drawing/2014/main" id="{22118601-1E52-5F04-32BD-8A3FC15A08BE}"/>
               </a:ext>
             </a:extLst>
           </p:cNvPr>
@@ -6020,7 +6015,7 @@
           <p:cNvPr id="9" name="Rectangle: Rounded Corners 8">
             <a:extLst>
               <a:ext uri="{FF2B5EF4-FFF2-40B4-BE49-F238E27FC236}">
-                <a16:creationId xmlns:a16="http://schemas.microsoft.com/office/drawing/2014/main" id="{507DFC6C-7AEE-CE87-1152-9B06D87B0EBD}"/>
+                <a16:creationId xmlns:a16="http://schemas.microsoft.com/office/drawing/2014/main" id="{797806BB-0A69-A930-9AB2-CFE7942440B5}"/>
               </a:ext>
             </a:extLst>
           </p:cNvPr>
@@ -6099,7 +6094,7 @@
           <p:cNvPr id="10" name="Rectangle: Rounded Corners 9">
             <a:extLst>
               <a:ext uri="{FF2B5EF4-FFF2-40B4-BE49-F238E27FC236}">
-                <a16:creationId xmlns:a16="http://schemas.microsoft.com/office/drawing/2014/main" id="{90D0A1C7-D1CA-7BD9-6727-D8BE55C0C2BE}"/>
+                <a16:creationId xmlns:a16="http://schemas.microsoft.com/office/drawing/2014/main" id="{1266BE63-7A48-1D8B-F344-65CC2BC5043B}"/>
               </a:ext>
             </a:extLst>
           </p:cNvPr>
@@ -6179,7 +6174,7 @@
           <p:cNvPr id="12" name="Picture 11">
             <a:extLst>
               <a:ext uri="{FF2B5EF4-FFF2-40B4-BE49-F238E27FC236}">
-                <a16:creationId xmlns:a16="http://schemas.microsoft.com/office/drawing/2014/main" id="{0A145BAC-A64A-D866-9C68-3ADA772850FD}"/>
+                <a16:creationId xmlns:a16="http://schemas.microsoft.com/office/drawing/2014/main" id="{09E7F706-F969-89AD-9C2F-7A262133A2F8}"/>
               </a:ext>
             </a:extLst>
           </p:cNvPr>
@@ -6215,7 +6210,7 @@
           <p:cNvPr id="13" name="Rectangle 12">
             <a:extLst>
               <a:ext uri="{FF2B5EF4-FFF2-40B4-BE49-F238E27FC236}">
-                <a16:creationId xmlns:a16="http://schemas.microsoft.com/office/drawing/2014/main" id="{AE6A8379-E0A9-95E7-E07F-BF8D591EE6DE}"/>
+                <a16:creationId xmlns:a16="http://schemas.microsoft.com/office/drawing/2014/main" id="{FA9C8BCC-2323-51D8-5ADF-E13D7892E807}"/>
               </a:ext>
             </a:extLst>
           </p:cNvPr>
@@ -6283,7 +6278,7 @@
           <p:cNvPr id="14" name="TextBox 13">
             <a:extLst>
               <a:ext uri="{FF2B5EF4-FFF2-40B4-BE49-F238E27FC236}">
-                <a16:creationId xmlns:a16="http://schemas.microsoft.com/office/drawing/2014/main" id="{025F2E7A-467B-FEA7-7340-87E579B9E6C3}"/>
+                <a16:creationId xmlns:a16="http://schemas.microsoft.com/office/drawing/2014/main" id="{754A348A-0081-C6A1-A634-72C99426AC9A}"/>
               </a:ext>
             </a:extLst>
           </p:cNvPr>
@@ -6325,7 +6320,7 @@
     </p:spTree>
     <p:extLst>
       <p:ext uri="{BB962C8B-B14F-4D97-AF65-F5344CB8AC3E}">
-        <p14:creationId xmlns:p14="http://schemas.microsoft.com/office/powerpoint/2010/main" val="1521677857"/>
+        <p14:creationId xmlns:p14="http://schemas.microsoft.com/office/powerpoint/2010/main" val="1734390239"/>
       </p:ext>
     </p:extLst>
   </p:cSld>
@@ -6357,7 +6352,7 @@
           <p:cNvPr id="2" name="Rectangle 1">
             <a:extLst>
               <a:ext uri="{FF2B5EF4-FFF2-40B4-BE49-F238E27FC236}">
-                <a16:creationId xmlns:a16="http://schemas.microsoft.com/office/drawing/2014/main" id="{4A9BF99E-4CE4-08E7-98B6-973C46B3D679}"/>
+                <a16:creationId xmlns:a16="http://schemas.microsoft.com/office/drawing/2014/main" id="{20C99066-ADF8-E6D8-5805-09E2A5F0FE82}"/>
               </a:ext>
             </a:extLst>
           </p:cNvPr>
@@ -6425,7 +6420,7 @@
           <p:cNvPr id="3" name="Rectangle 2">
             <a:extLst>
               <a:ext uri="{FF2B5EF4-FFF2-40B4-BE49-F238E27FC236}">
-                <a16:creationId xmlns:a16="http://schemas.microsoft.com/office/drawing/2014/main" id="{DD65D179-FBF4-E5A7-E8BF-89B71FBB7B04}"/>
+                <a16:creationId xmlns:a16="http://schemas.microsoft.com/office/drawing/2014/main" id="{8B3D2D6A-07C6-0FAA-88E5-BFEF28619D0F}"/>
               </a:ext>
             </a:extLst>
           </p:cNvPr>
@@ -6493,7 +6488,7 @@
           <p:cNvPr id="4" name="Rectangle: Rounded Corners 3">
             <a:extLst>
               <a:ext uri="{FF2B5EF4-FFF2-40B4-BE49-F238E27FC236}">
-                <a16:creationId xmlns:a16="http://schemas.microsoft.com/office/drawing/2014/main" id="{E0E8A32A-D069-BCDA-BF63-1B002338EA69}"/>
+                <a16:creationId xmlns:a16="http://schemas.microsoft.com/office/drawing/2014/main" id="{F22BF98F-C5F8-F612-E014-DCE4E0D162A7}"/>
               </a:ext>
             </a:extLst>
           </p:cNvPr>
@@ -6568,7 +6563,7 @@
           <p:cNvPr id="5" name="TextBox 4">
             <a:extLst>
               <a:ext uri="{FF2B5EF4-FFF2-40B4-BE49-F238E27FC236}">
-                <a16:creationId xmlns:a16="http://schemas.microsoft.com/office/drawing/2014/main" id="{3C765EBF-7A9E-C512-DF03-3FF0D3901609}"/>
+                <a16:creationId xmlns:a16="http://schemas.microsoft.com/office/drawing/2014/main" id="{7CA2DF1C-1EC7-D8DA-31F2-880784877225}"/>
               </a:ext>
             </a:extLst>
           </p:cNvPr>
@@ -6612,7 +6607,7 @@
           <p:cNvPr id="6" name="Rectangle: Rounded Corners 5">
             <a:extLst>
               <a:ext uri="{FF2B5EF4-FFF2-40B4-BE49-F238E27FC236}">
-                <a16:creationId xmlns:a16="http://schemas.microsoft.com/office/drawing/2014/main" id="{D0BA8A80-4766-C796-AAA8-974950462F81}"/>
+                <a16:creationId xmlns:a16="http://schemas.microsoft.com/office/drawing/2014/main" id="{B85BBFBA-89D5-163D-A340-C1FFE9792C2B}"/>
               </a:ext>
             </a:extLst>
           </p:cNvPr>
@@ -6673,7 +6668,7 @@
           <p:cNvPr id="7" name="Rectangle: Rounded Corners 6">
             <a:extLst>
               <a:ext uri="{FF2B5EF4-FFF2-40B4-BE49-F238E27FC236}">
-                <a16:creationId xmlns:a16="http://schemas.microsoft.com/office/drawing/2014/main" id="{7834F694-75AF-ACC3-E4C4-25AB95F990CB}"/>
+                <a16:creationId xmlns:a16="http://schemas.microsoft.com/office/drawing/2014/main" id="{510D6668-9426-4B38-C158-20DF73B7D5F9}"/>
               </a:ext>
             </a:extLst>
           </p:cNvPr>
@@ -6753,7 +6748,7 @@
           <p:cNvPr id="8" name="Rectangle: Rounded Corners 7">
             <a:extLst>
               <a:ext uri="{FF2B5EF4-FFF2-40B4-BE49-F238E27FC236}">
-                <a16:creationId xmlns:a16="http://schemas.microsoft.com/office/drawing/2014/main" id="{45E00ED5-1C42-EF65-25A5-6B4D8C8F6619}"/>
+                <a16:creationId xmlns:a16="http://schemas.microsoft.com/office/drawing/2014/main" id="{11C5D840-A86D-59F5-50D4-FCEC79F71B68}"/>
               </a:ext>
             </a:extLst>
           </p:cNvPr>
@@ -6833,7 +6828,7 @@
           <p:cNvPr id="9" name="Rectangle: Rounded Corners 8">
             <a:extLst>
               <a:ext uri="{FF2B5EF4-FFF2-40B4-BE49-F238E27FC236}">
-                <a16:creationId xmlns:a16="http://schemas.microsoft.com/office/drawing/2014/main" id="{A6682726-B5FF-4CEE-2234-16A131EC15AC}"/>
+                <a16:creationId xmlns:a16="http://schemas.microsoft.com/office/drawing/2014/main" id="{4CE09375-54E5-3F9D-6548-32408FF11241}"/>
               </a:ext>
             </a:extLst>
           </p:cNvPr>
@@ -6912,7 +6907,7 @@
           <p:cNvPr id="10" name="Rectangle: Rounded Corners 9">
             <a:extLst>
               <a:ext uri="{FF2B5EF4-FFF2-40B4-BE49-F238E27FC236}">
-                <a16:creationId xmlns:a16="http://schemas.microsoft.com/office/drawing/2014/main" id="{E4AFB4D9-D2D8-EDD4-D984-8EFBE7442E53}"/>
+                <a16:creationId xmlns:a16="http://schemas.microsoft.com/office/drawing/2014/main" id="{19E20372-02F2-6025-536C-ECFAAB1A83A8}"/>
               </a:ext>
             </a:extLst>
           </p:cNvPr>
@@ -6989,7 +6984,7 @@
           <p:cNvPr id="12" name="Picture 11">
             <a:extLst>
               <a:ext uri="{FF2B5EF4-FFF2-40B4-BE49-F238E27FC236}">
-                <a16:creationId xmlns:a16="http://schemas.microsoft.com/office/drawing/2014/main" id="{B55D198C-C22A-2F01-DAB5-F53B19C7EC0E}"/>
+                <a16:creationId xmlns:a16="http://schemas.microsoft.com/office/drawing/2014/main" id="{9B6C502C-E353-5349-F6AC-D9FD6E92CD4B}"/>
               </a:ext>
             </a:extLst>
           </p:cNvPr>
@@ -7025,7 +7020,7 @@
           <p:cNvPr id="13" name="Rectangle 12">
             <a:extLst>
               <a:ext uri="{FF2B5EF4-FFF2-40B4-BE49-F238E27FC236}">
-                <a16:creationId xmlns:a16="http://schemas.microsoft.com/office/drawing/2014/main" id="{AE994698-0AC9-9E1A-93F3-2095CAD25896}"/>
+                <a16:creationId xmlns:a16="http://schemas.microsoft.com/office/drawing/2014/main" id="{85258FD7-E7C7-6B35-2919-C83864E3CBCC}"/>
               </a:ext>
             </a:extLst>
           </p:cNvPr>
@@ -7093,7 +7088,7 @@
           <p:cNvPr id="14" name="TextBox 13">
             <a:extLst>
               <a:ext uri="{FF2B5EF4-FFF2-40B4-BE49-F238E27FC236}">
-                <a16:creationId xmlns:a16="http://schemas.microsoft.com/office/drawing/2014/main" id="{E0975C6A-36CB-6150-7D17-99E26F97BBEA}"/>
+                <a16:creationId xmlns:a16="http://schemas.microsoft.com/office/drawing/2014/main" id="{720135DB-268E-D991-DA90-9B72BD75F3D6}"/>
               </a:ext>
             </a:extLst>
           </p:cNvPr>
@@ -7135,7 +7130,7 @@
     </p:spTree>
     <p:extLst>
       <p:ext uri="{BB962C8B-B14F-4D97-AF65-F5344CB8AC3E}">
-        <p14:creationId xmlns:p14="http://schemas.microsoft.com/office/powerpoint/2010/main" val="2917187042"/>
+        <p14:creationId xmlns:p14="http://schemas.microsoft.com/office/powerpoint/2010/main" val="3697431611"/>
       </p:ext>
     </p:extLst>
   </p:cSld>
@@ -7167,7 +7162,7 @@
           <p:cNvPr id="2" name="Rectangle 1">
             <a:extLst>
               <a:ext uri="{FF2B5EF4-FFF2-40B4-BE49-F238E27FC236}">
-                <a16:creationId xmlns:a16="http://schemas.microsoft.com/office/drawing/2014/main" id="{6151E884-8046-2C85-8D94-3E84C94C4BAF}"/>
+                <a16:creationId xmlns:a16="http://schemas.microsoft.com/office/drawing/2014/main" id="{7C6A1580-A8C3-1573-B304-AC88BA0573C6}"/>
               </a:ext>
             </a:extLst>
           </p:cNvPr>
@@ -7235,7 +7230,7 @@
           <p:cNvPr id="3" name="Rectangle 2">
             <a:extLst>
               <a:ext uri="{FF2B5EF4-FFF2-40B4-BE49-F238E27FC236}">
-                <a16:creationId xmlns:a16="http://schemas.microsoft.com/office/drawing/2014/main" id="{1FC19AFC-01ED-4E8E-7F1B-EA6420588D5E}"/>
+                <a16:creationId xmlns:a16="http://schemas.microsoft.com/office/drawing/2014/main" id="{84F87CEB-0BDE-EE5A-B0DD-676CC0847E09}"/>
               </a:ext>
             </a:extLst>
           </p:cNvPr>
@@ -7303,7 +7298,7 @@
           <p:cNvPr id="4" name="Rectangle: Rounded Corners 3">
             <a:extLst>
               <a:ext uri="{FF2B5EF4-FFF2-40B4-BE49-F238E27FC236}">
-                <a16:creationId xmlns:a16="http://schemas.microsoft.com/office/drawing/2014/main" id="{6D1A8D9B-C629-B756-05EB-8F31803E35F8}"/>
+                <a16:creationId xmlns:a16="http://schemas.microsoft.com/office/drawing/2014/main" id="{C300FDCE-8C16-C6F5-242C-8CF39541DF6F}"/>
               </a:ext>
             </a:extLst>
           </p:cNvPr>
@@ -7378,7 +7373,7 @@
           <p:cNvPr id="5" name="TextBox 4">
             <a:extLst>
               <a:ext uri="{FF2B5EF4-FFF2-40B4-BE49-F238E27FC236}">
-                <a16:creationId xmlns:a16="http://schemas.microsoft.com/office/drawing/2014/main" id="{8633D16B-932F-FA31-5DB4-BE1BB2A994E5}"/>
+                <a16:creationId xmlns:a16="http://schemas.microsoft.com/office/drawing/2014/main" id="{C8555DA5-DDB9-366F-CAD0-0F4D05D3E293}"/>
               </a:ext>
             </a:extLst>
           </p:cNvPr>
@@ -7417,7 +7412,7 @@
           <p:cNvPr id="6" name="Rectangle: Rounded Corners 5">
             <a:extLst>
               <a:ext uri="{FF2B5EF4-FFF2-40B4-BE49-F238E27FC236}">
-                <a16:creationId xmlns:a16="http://schemas.microsoft.com/office/drawing/2014/main" id="{2B19BC42-7D24-4BE3-2DE8-3BA127ABB661}"/>
+                <a16:creationId xmlns:a16="http://schemas.microsoft.com/office/drawing/2014/main" id="{7E8E5E0F-78DC-28AD-033F-CC56BF8C7671}"/>
               </a:ext>
             </a:extLst>
           </p:cNvPr>
@@ -7478,7 +7473,7 @@
           <p:cNvPr id="7" name="Rectangle: Rounded Corners 6">
             <a:extLst>
               <a:ext uri="{FF2B5EF4-FFF2-40B4-BE49-F238E27FC236}">
-                <a16:creationId xmlns:a16="http://schemas.microsoft.com/office/drawing/2014/main" id="{E382A86E-B636-79AF-A574-5619CC4C2722}"/>
+                <a16:creationId xmlns:a16="http://schemas.microsoft.com/office/drawing/2014/main" id="{30975815-4206-528C-075E-952C5D2BF567}"/>
               </a:ext>
             </a:extLst>
           </p:cNvPr>
@@ -7557,7 +7552,7 @@
           <p:cNvPr id="8" name="Rectangle: Rounded Corners 7">
             <a:extLst>
               <a:ext uri="{FF2B5EF4-FFF2-40B4-BE49-F238E27FC236}">
-                <a16:creationId xmlns:a16="http://schemas.microsoft.com/office/drawing/2014/main" id="{7B78D743-D96E-06C3-E8F9-D8AF70569A99}"/>
+                <a16:creationId xmlns:a16="http://schemas.microsoft.com/office/drawing/2014/main" id="{FA0634E3-6126-1C25-3ED6-9E80F8F76F2E}"/>
               </a:ext>
             </a:extLst>
           </p:cNvPr>
@@ -7636,7 +7631,7 @@
           <p:cNvPr id="9" name="Rectangle: Rounded Corners 8">
             <a:extLst>
               <a:ext uri="{FF2B5EF4-FFF2-40B4-BE49-F238E27FC236}">
-                <a16:creationId xmlns:a16="http://schemas.microsoft.com/office/drawing/2014/main" id="{336803AC-3CD2-CB7B-1E59-DFC46195C823}"/>
+                <a16:creationId xmlns:a16="http://schemas.microsoft.com/office/drawing/2014/main" id="{1CC13EDE-5A7C-ECAD-1A45-2391D6AC87D3}"/>
               </a:ext>
             </a:extLst>
           </p:cNvPr>
@@ -7715,7 +7710,7 @@
           <p:cNvPr id="10" name="Rectangle: Rounded Corners 9">
             <a:extLst>
               <a:ext uri="{FF2B5EF4-FFF2-40B4-BE49-F238E27FC236}">
-                <a16:creationId xmlns:a16="http://schemas.microsoft.com/office/drawing/2014/main" id="{CC6FBB9F-4834-E6BB-0C43-66F7817C0815}"/>
+                <a16:creationId xmlns:a16="http://schemas.microsoft.com/office/drawing/2014/main" id="{49CC6438-73C4-6A4E-7BEC-39DEBFF9294B}"/>
               </a:ext>
             </a:extLst>
           </p:cNvPr>
@@ -7766,7 +7761,7 @@
                   <a:srgbClr val="FFB300"/>
                 </a:solidFill>
               </a:rPr>
-              <a:t>⚙️ Industry Protocols &amp; Communication Standards</a:t>
+              <a:t>💻 Open-Source GitHub Repository &amp; Live Mission Hub</a:t>
             </a:r>
           </a:p>
           <a:p>
@@ -7777,14 +7772,14 @@
                   <a:srgbClr val="94A3B8"/>
                 </a:solidFill>
               </a:rPr>
-              <a:t>• LoRa Alliance: LoRaWAN Sub-GHz Mesh Specifications (868/915 MHz).</a:t>
+              <a:t>• GitHub: github.com/harshitsharma120109-web/ARIES-Search-Rescue-Rover</a:t>
             </a:r>
           </a:p>
           <a:p>
             <a:pPr algn="ctr"/>
             <a:r>
               <a:rPr lang="en-IN"/>
-              <a:t>• 3GPP TS 27.007: Cellular AT Command Standard for Emergency Alert Dispatch.</a:t>
+              <a:t>• Live Web Dashboard: joyful-cactus-9b247c.netlify.app</a:t>
             </a:r>
           </a:p>
         </p:txBody>
@@ -7794,7 +7789,7 @@
           <p:cNvPr id="12" name="Picture 11">
             <a:extLst>
               <a:ext uri="{FF2B5EF4-FFF2-40B4-BE49-F238E27FC236}">
-                <a16:creationId xmlns:a16="http://schemas.microsoft.com/office/drawing/2014/main" id="{F601CA02-A9DB-0D67-724E-A71C4A18C2BA}"/>
+                <a16:creationId xmlns:a16="http://schemas.microsoft.com/office/drawing/2014/main" id="{F0216083-B181-2797-4974-BE22B3C46FE5}"/>
               </a:ext>
             </a:extLst>
           </p:cNvPr>
@@ -7830,7 +7825,7 @@
           <p:cNvPr id="13" name="Rectangle 12">
             <a:extLst>
               <a:ext uri="{FF2B5EF4-FFF2-40B4-BE49-F238E27FC236}">
-                <a16:creationId xmlns:a16="http://schemas.microsoft.com/office/drawing/2014/main" id="{C09909A8-6C41-82B0-4D06-0C3340B4ED98}"/>
+                <a16:creationId xmlns:a16="http://schemas.microsoft.com/office/drawing/2014/main" id="{81263530-54D4-5CDB-7C8A-3EFF1EAE05D3}"/>
               </a:ext>
             </a:extLst>
           </p:cNvPr>
@@ -7898,7 +7893,7 @@
           <p:cNvPr id="14" name="TextBox 13">
             <a:extLst>
               <a:ext uri="{FF2B5EF4-FFF2-40B4-BE49-F238E27FC236}">
-                <a16:creationId xmlns:a16="http://schemas.microsoft.com/office/drawing/2014/main" id="{C6A1E966-DBF9-C3A3-F683-4E8DB31E5EF3}"/>
+                <a16:creationId xmlns:a16="http://schemas.microsoft.com/office/drawing/2014/main" id="{8E02AD74-63E4-34F1-DB96-427BEBD73DFD}"/>
               </a:ext>
             </a:extLst>
           </p:cNvPr>
@@ -7922,25 +7917,20 @@
           <a:lstStyle/>
           <a:p>
             <a:r>
-              <a:rPr lang="en-US" sz="1100" b="1">
+              <a:rPr lang="en-IN" sz="1100" b="1">
                 <a:solidFill>
                   <a:srgbClr val="FFB300"/>
                 </a:solidFill>
               </a:rPr>
-              <a:t>Grounded in Authoritative Standards: Aligned with NDMA national safety benchmarks and peer-reviewed USAR robotics research.</a:t>
-            </a:r>
-            <a:endParaRPr lang="en-IN" sz="1100" b="1">
-              <a:solidFill>
-                <a:srgbClr val="FFB300"/>
-              </a:solidFill>
-            </a:endParaRPr>
+              <a:t>Official Repo: github.com/harshitsharma120109-web/ARIES-Search-Rescue-Rover   |   Live Console: joyful-cactus-9b247c.netlify.app</a:t>
+            </a:r>
           </a:p>
         </p:txBody>
       </p:sp>
     </p:spTree>
     <p:extLst>
       <p:ext uri="{BB962C8B-B14F-4D97-AF65-F5344CB8AC3E}">
-        <p14:creationId xmlns:p14="http://schemas.microsoft.com/office/powerpoint/2010/main" val="391262205"/>
+        <p14:creationId xmlns:p14="http://schemas.microsoft.com/office/powerpoint/2010/main" val="178897216"/>
       </p:ext>
     </p:extLst>
   </p:cSld>

</xml_diff>